<commit_message>
Fixed rebase issue; updated names
</commit_message>
<xml_diff>
--- a/Calgary_Traffic_Midpoint.pptx
+++ b/Calgary_Traffic_Midpoint.pptx
@@ -2978,9 +2978,6 @@
           <a:bodyPr wrap="square" lIns="0" tIns="0" rIns="0" bIns="0" rtlCol="0" anchor="t"/>
           <a:lstStyle/>
           <a:p>
-            <a:pPr marL="0" indent="0">
-              <a:buNone/>
-            </a:pPr>
             <a:r>
               <a:rPr lang="en-US" sz="1400" dirty="0">
                 <a:solidFill>
@@ -2990,7 +2987,40 @@
                 <a:ea typeface="Public Sans" pitchFamily="34" charset="-122"/>
                 <a:cs typeface="Public Sans" pitchFamily="34" charset="-120"/>
               </a:rPr>
-              <a:t>Adrian Julve · Data 201 · Oct 20</a:t>
+              <a:t>Adrian </a:t>
+            </a:r>
+            <a:r>
+              <a:rPr lang="en-US" sz="1400">
+                <a:solidFill>
+                  <a:srgbClr val="C9C7CF"/>
+                </a:solidFill>
+                <a:latin typeface="Public Sans" pitchFamily="34" charset="0"/>
+                <a:ea typeface="Public Sans" pitchFamily="34" charset="-122"/>
+                <a:cs typeface="Public Sans" pitchFamily="34" charset="-120"/>
+              </a:rPr>
+              <a:t>Julve, Kein </a:t>
+            </a:r>
+            <a:r>
+              <a:rPr lang="en-US" sz="1400" dirty="0" err="1">
+                <a:solidFill>
+                  <a:srgbClr val="C9C7CF"/>
+                </a:solidFill>
+                <a:latin typeface="Public Sans" pitchFamily="34" charset="0"/>
+                <a:ea typeface="Public Sans" pitchFamily="34" charset="-122"/>
+                <a:cs typeface="Public Sans" pitchFamily="34" charset="-120"/>
+              </a:rPr>
+              <a:t>Ritarita</a:t>
+            </a:r>
+            <a:r>
+              <a:rPr lang="en-US" sz="1400" dirty="0">
+                <a:solidFill>
+                  <a:srgbClr val="C9C7CF"/>
+                </a:solidFill>
+                <a:latin typeface="Public Sans" pitchFamily="34" charset="0"/>
+                <a:ea typeface="Public Sans" pitchFamily="34" charset="-122"/>
+                <a:cs typeface="Public Sans" pitchFamily="34" charset="-120"/>
+              </a:rPr>
+              <a:t> · Data 201 · Oct 20</a:t>
             </a:r>
             <a:r>
               <a:rPr lang="en-US" sz="1400" baseline="30000" dirty="0">

</xml_diff>

<commit_message>
Updated Data Wrangling Slide
</commit_message>
<xml_diff>
--- a/Calgary_Traffic_Midpoint.pptx
+++ b/Calgary_Traffic_Midpoint.pptx
@@ -6,7 +6,7 @@
     <p:sldMasterId id="2147483654" r:id="rId2"/>
   </p:sldMasterIdLst>
   <p:notesMasterIdLst>
-    <p:notesMasterId r:id="rId12"/>
+    <p:notesMasterId r:id="rId13"/>
   </p:notesMasterIdLst>
   <p:sldIdLst>
     <p:sldId id="256" r:id="rId3"/>
@@ -14,10 +14,11 @@
     <p:sldId id="258" r:id="rId5"/>
     <p:sldId id="259" r:id="rId6"/>
     <p:sldId id="265" r:id="rId7"/>
-    <p:sldId id="269" r:id="rId8"/>
-    <p:sldId id="270" r:id="rId9"/>
-    <p:sldId id="263" r:id="rId10"/>
-    <p:sldId id="268" r:id="rId11"/>
+    <p:sldId id="260" r:id="rId8"/>
+    <p:sldId id="269" r:id="rId9"/>
+    <p:sldId id="270" r:id="rId10"/>
+    <p:sldId id="263" r:id="rId11"/>
+    <p:sldId id="268" r:id="rId12"/>
   </p:sldIdLst>
   <p:sldSz cx="12192000" cy="6858000"/>
   <p:notesSz cx="6858000" cy="12192000"/>
@@ -131,6 +132,7 @@
         <p14:section name="Wrangling" id="{3AE2D310-56C6-B243-413B-9658E54EA91D}">
           <p14:sldIdLst>
             <p14:sldId id="265"/>
+            <p14:sldId id="260"/>
           </p14:sldIdLst>
         </p14:section>
         <p14:section name="Visualizations and findings" id="{FA1E9DF6-5D12-0988-0309-B8E845309660}">
@@ -551,7 +553,7 @@
 </p:notes>
 </file>
 
-<file path=ppt/notesSlides/notesSlide2.xml><?xml version="1.0" encoding="utf-8"?>
+<file path=ppt/notesSlides/notesSlide10.xml><?xml version="1.0" encoding="utf-8"?>
 <p:notes xmlns:a="http://schemas.openxmlformats.org/drawingml/2006/main" xmlns:r="http://schemas.openxmlformats.org/officeDocument/2006/relationships" xmlns:p="http://schemas.openxmlformats.org/presentationml/2006/main">
   <p:cSld>
     <p:spTree>
@@ -597,355 +599,7 @@
           <a:p>
             <a:r>
               <a:rPr lang="en-US" dirty="0"/>
-              <a:t>Traffic incidents aren’t random. They cluster on certain roads, at certain times, and in certain parts of the city. My project uses City of Calgary open data to ask whether neighbourhood income and related conditions, like renting, low income and how people commute, line up with where incidents happen. The study area is the whole city, split into 113 community service areas. I use nine complete years, 2017 to 2025, and the result is an interactive Power BI dashboard.</a:t>
-            </a:r>
-          </a:p>
-        </p:txBody>
-      </p:sp>
-      <p:sp>
-        <p:nvSpPr>
-          <p:cNvPr id="4" name="Slide Number Placeholder 3"/>
-          <p:cNvSpPr>
-            <a:spLocks noGrp="1"/>
-          </p:cNvSpPr>
-          <p:nvPr>
-            <p:ph type="sldNum" sz="quarter" idx="10"/>
-          </p:nvPr>
-        </p:nvSpPr>
-        <p:spPr/>
-        <p:txBody>
-          <a:bodyPr/>
-          <a:lstStyle/>
-          <a:p>
-            <a:fld id="{F7021451-1387-4CA6-816F-3879F97B5CBC}" type="slidenum">
-              <a:rPr lang="en-US"/>
-              <a:t>2</a:t>
-            </a:fld>
-            <a:endParaRPr lang="en-US"/>
-          </a:p>
-        </p:txBody>
-      </p:sp>
-    </p:spTree>
-    <p:extLst>
-      <p:ext uri="{BB962C8B-B14F-4D97-AF65-F5344CB8AC3E}">
-        <p14:creationId xmlns:p14="http://schemas.microsoft.com/office/powerpoint/2010/main" val="1024086991"/>
-      </p:ext>
-    </p:extLst>
-  </p:cSld>
-  <p:clrMapOvr>
-    <a:masterClrMapping/>
-  </p:clrMapOvr>
-</p:notes>
-</file>
-
-<file path=ppt/notesSlides/notesSlide3.xml><?xml version="1.0" encoding="utf-8"?>
-<p:notes xmlns:a="http://schemas.openxmlformats.org/drawingml/2006/main" xmlns:r="http://schemas.openxmlformats.org/officeDocument/2006/relationships" xmlns:p="http://schemas.openxmlformats.org/presentationml/2006/main">
-  <p:cSld>
-    <p:spTree>
-      <p:nvGrpSpPr>
-        <p:cNvPr id="1" name=""/>
-        <p:cNvGrpSpPr/>
-        <p:nvPr/>
-      </p:nvGrpSpPr>
-      <p:grpSpPr>
-        <a:xfrm>
-          <a:off x="0" y="0"/>
-          <a:ext cx="0" cy="0"/>
-          <a:chOff x="0" y="0"/>
-          <a:chExt cx="0" cy="0"/>
-        </a:xfrm>
-      </p:grpSpPr>
-      <p:sp>
-        <p:nvSpPr>
-          <p:cNvPr id="2" name="Slide Image Placeholder 1"/>
-          <p:cNvSpPr>
-            <a:spLocks noGrp="1" noRot="1" noChangeAspect="1"/>
-          </p:cNvSpPr>
-          <p:nvPr>
-            <p:ph type="sldImg"/>
-          </p:nvPr>
-        </p:nvSpPr>
-        <p:spPr/>
-      </p:sp>
-      <p:sp>
-        <p:nvSpPr>
-          <p:cNvPr id="3" name="Notes Placeholder 2"/>
-          <p:cNvSpPr>
-            <a:spLocks noGrp="1"/>
-          </p:cNvSpPr>
-          <p:nvPr>
-            <p:ph type="body" idx="1"/>
-          </p:nvPr>
-        </p:nvSpPr>
-        <p:spPr/>
-        <p:txBody>
-          <a:bodyPr/>
-          <a:lstStyle/>
-          <a:p>
-            <a:r>
-              <a:rPr lang="en-US" dirty="0"/>
-              <a:t>I have three questions. First, where: once we account for how many people live in an area, where do incidents concentrate, and does that match neighbourhood income? Second, who: beyond income, which neighbourhood traits, like renting, low income or commuting by car, go along with higher incident rates? Third, when: what times of day, days of the week and months of the year see the most incidents? Each question maps to a part of the dashboard.</a:t>
-            </a:r>
-          </a:p>
-        </p:txBody>
-      </p:sp>
-      <p:sp>
-        <p:nvSpPr>
-          <p:cNvPr id="4" name="Slide Number Placeholder 3"/>
-          <p:cNvSpPr>
-            <a:spLocks noGrp="1"/>
-          </p:cNvSpPr>
-          <p:nvPr>
-            <p:ph type="sldNum" sz="quarter" idx="10"/>
-          </p:nvPr>
-        </p:nvSpPr>
-        <p:spPr/>
-        <p:txBody>
-          <a:bodyPr/>
-          <a:lstStyle/>
-          <a:p>
-            <a:fld id="{F7021451-1387-4CA6-816F-3879F97B5CBC}" type="slidenum">
-              <a:rPr lang="en-US"/>
-              <a:t>3</a:t>
-            </a:fld>
-            <a:endParaRPr lang="en-US"/>
-          </a:p>
-        </p:txBody>
-      </p:sp>
-    </p:spTree>
-    <p:extLst>
-      <p:ext uri="{BB962C8B-B14F-4D97-AF65-F5344CB8AC3E}">
-        <p14:creationId xmlns:p14="http://schemas.microsoft.com/office/powerpoint/2010/main" val="1024086991"/>
-      </p:ext>
-    </p:extLst>
-  </p:cSld>
-  <p:clrMapOvr>
-    <a:masterClrMapping/>
-  </p:clrMapOvr>
-</p:notes>
-</file>
-
-<file path=ppt/notesSlides/notesSlide4.xml><?xml version="1.0" encoding="utf-8"?>
-<p:notes xmlns:a="http://schemas.openxmlformats.org/drawingml/2006/main" xmlns:r="http://schemas.openxmlformats.org/officeDocument/2006/relationships" xmlns:p="http://schemas.openxmlformats.org/presentationml/2006/main">
-  <p:cSld>
-    <p:spTree>
-      <p:nvGrpSpPr>
-        <p:cNvPr id="1" name=""/>
-        <p:cNvGrpSpPr/>
-        <p:nvPr/>
-      </p:nvGrpSpPr>
-      <p:grpSpPr>
-        <a:xfrm>
-          <a:off x="0" y="0"/>
-          <a:ext cx="0" cy="0"/>
-          <a:chOff x="0" y="0"/>
-          <a:chExt cx="0" cy="0"/>
-        </a:xfrm>
-      </p:grpSpPr>
-      <p:sp>
-        <p:nvSpPr>
-          <p:cNvPr id="2" name="Slide Image Placeholder 1"/>
-          <p:cNvSpPr>
-            <a:spLocks noGrp="1" noRot="1" noChangeAspect="1"/>
-          </p:cNvSpPr>
-          <p:nvPr>
-            <p:ph type="sldImg"/>
-          </p:nvPr>
-        </p:nvSpPr>
-        <p:spPr/>
-      </p:sp>
-      <p:sp>
-        <p:nvSpPr>
-          <p:cNvPr id="3" name="Notes Placeholder 2"/>
-          <p:cNvSpPr>
-            <a:spLocks noGrp="1"/>
-          </p:cNvSpPr>
-          <p:nvPr>
-            <p:ph type="body" idx="1"/>
-          </p:nvPr>
-        </p:nvSpPr>
-        <p:spPr/>
-        <p:txBody>
-          <a:bodyPr/>
-          <a:lstStyle/>
-          <a:p>
-            <a:r>
-              <a:rPr lang="en-US" dirty="0"/>
-              <a:t>All three datasets come from the City of Calgary’s open data portal, and all are obtained. Traffic Incidents is the core: 65,138 records, each with a location, description and timestamp. The Equity Index file covers 113 community service areas with population, median income and 16 other census measures, plus their boundaries. Community District Boundaries adds 313 communities with their land-use class, which lets me separate residential areas from industrial ones.</a:t>
-            </a:r>
-          </a:p>
-        </p:txBody>
-      </p:sp>
-      <p:sp>
-        <p:nvSpPr>
-          <p:cNvPr id="4" name="Slide Number Placeholder 3"/>
-          <p:cNvSpPr>
-            <a:spLocks noGrp="1"/>
-          </p:cNvSpPr>
-          <p:nvPr>
-            <p:ph type="sldNum" sz="quarter" idx="10"/>
-          </p:nvPr>
-        </p:nvSpPr>
-        <p:spPr/>
-        <p:txBody>
-          <a:bodyPr/>
-          <a:lstStyle/>
-          <a:p>
-            <a:fld id="{F7021451-1387-4CA6-816F-3879F97B5CBC}" type="slidenum">
-              <a:rPr lang="en-US"/>
-              <a:t>4</a:t>
-            </a:fld>
-            <a:endParaRPr lang="en-US"/>
-          </a:p>
-        </p:txBody>
-      </p:sp>
-    </p:spTree>
-    <p:extLst>
-      <p:ext uri="{BB962C8B-B14F-4D97-AF65-F5344CB8AC3E}">
-        <p14:creationId xmlns:p14="http://schemas.microsoft.com/office/powerpoint/2010/main" val="1024086991"/>
-      </p:ext>
-    </p:extLst>
-  </p:cSld>
-  <p:clrMapOvr>
-    <a:masterClrMapping/>
-  </p:clrMapOvr>
-</p:notes>
-</file>
-
-<file path=ppt/notesSlides/notesSlide5.xml><?xml version="1.0" encoding="utf-8"?>
-<p:notes xmlns:a="http://schemas.openxmlformats.org/drawingml/2006/main" xmlns:r="http://schemas.openxmlformats.org/officeDocument/2006/relationships" xmlns:p="http://schemas.openxmlformats.org/presentationml/2006/main">
-  <p:cSld>
-    <p:spTree>
-      <p:nvGrpSpPr>
-        <p:cNvPr id="1" name=""/>
-        <p:cNvGrpSpPr/>
-        <p:nvPr/>
-      </p:nvGrpSpPr>
-      <p:grpSpPr>
-        <a:xfrm>
-          <a:off x="0" y="0"/>
-          <a:ext cx="0" cy="0"/>
-          <a:chOff x="0" y="0"/>
-          <a:chExt cx="0" cy="0"/>
-        </a:xfrm>
-      </p:grpSpPr>
-      <p:sp>
-        <p:nvSpPr>
-          <p:cNvPr id="2" name="Slide Image Placeholder 1"/>
-          <p:cNvSpPr>
-            <a:spLocks noGrp="1" noRot="1" noChangeAspect="1"/>
-          </p:cNvSpPr>
-          <p:nvPr>
-            <p:ph type="sldImg"/>
-          </p:nvPr>
-        </p:nvSpPr>
-        <p:spPr/>
-      </p:sp>
-      <p:sp>
-        <p:nvSpPr>
-          <p:cNvPr id="3" name="Notes Placeholder 2"/>
-          <p:cNvSpPr>
-            <a:spLocks noGrp="1"/>
-          </p:cNvSpPr>
-          <p:nvPr>
-            <p:ph type="body" idx="1"/>
-          </p:nvPr>
-        </p:nvSpPr>
-        <p:spPr/>
-        <p:txBody>
-          <a:bodyPr/>
-          <a:lstStyle/>
-          <a:p>
-            <a:r>
-              <a:rPr lang="en-US" dirty="0"/>
-              <a:t>Here’s how I prepared the data. First, each incident only had a map point, so I used Python to read every area’s boundary outline and check which outline contains each point. This is called a point-in-polygon test. 785 incidents fall outside every area and stay unassigned. Second, the census file had one row per measure, so I reshaped it to one row per area and cleaned up the number formats. Third, I set each incident’s type from keywords in its description and flagged highway incidents by street name. Fourth, I filtered to the nine complete years, which leaves 58,536 incidents. Fifth, to compare areas fairly, I divided each area’s incidents by its population and the nine years, using only local roads in residential communities. Finally, I wrote DAX measures that power the dashboard: each selection’s rate compared with the city average, the busiest hour, a monthly rate that adjusts for missing data, and the correlations between neighbourhood traits and incident rates.</a:t>
-            </a:r>
-          </a:p>
-        </p:txBody>
-      </p:sp>
-      <p:sp>
-        <p:nvSpPr>
-          <p:cNvPr id="4" name="Slide Number Placeholder 3"/>
-          <p:cNvSpPr>
-            <a:spLocks noGrp="1"/>
-          </p:cNvSpPr>
-          <p:nvPr>
-            <p:ph type="sldNum" sz="quarter" idx="10"/>
-          </p:nvPr>
-        </p:nvSpPr>
-        <p:spPr/>
-        <p:txBody>
-          <a:bodyPr/>
-          <a:lstStyle/>
-          <a:p>
-            <a:fld id="{F7021451-1387-4CA6-816F-3879F97B5CBC}" type="slidenum">
-              <a:rPr lang="en-US"/>
-              <a:t>5</a:t>
-            </a:fld>
-            <a:endParaRPr lang="en-US"/>
-          </a:p>
-        </p:txBody>
-      </p:sp>
-    </p:spTree>
-    <p:extLst>
-      <p:ext uri="{BB962C8B-B14F-4D97-AF65-F5344CB8AC3E}">
-        <p14:creationId xmlns:p14="http://schemas.microsoft.com/office/powerpoint/2010/main" val="1024086991"/>
-      </p:ext>
-    </p:extLst>
-  </p:cSld>
-  <p:clrMapOvr>
-    <a:masterClrMapping/>
-  </p:clrMapOvr>
-</p:notes>
-</file>
-
-<file path=ppt/notesSlides/notesSlide6.xml><?xml version="1.0" encoding="utf-8"?>
-<p:notes xmlns:a="http://schemas.openxmlformats.org/drawingml/2006/main" xmlns:r="http://schemas.openxmlformats.org/officeDocument/2006/relationships" xmlns:p="http://schemas.openxmlformats.org/presentationml/2006/main">
-  <p:cSld>
-    <p:spTree>
-      <p:nvGrpSpPr>
-        <p:cNvPr id="1" name=""/>
-        <p:cNvGrpSpPr/>
-        <p:nvPr/>
-      </p:nvGrpSpPr>
-      <p:grpSpPr>
-        <a:xfrm>
-          <a:off x="0" y="0"/>
-          <a:ext cx="0" cy="0"/>
-          <a:chOff x="0" y="0"/>
-          <a:chExt cx="0" cy="0"/>
-        </a:xfrm>
-      </p:grpSpPr>
-      <p:sp>
-        <p:nvSpPr>
-          <p:cNvPr id="2" name="Slide Image Placeholder 1"/>
-          <p:cNvSpPr>
-            <a:spLocks noGrp="1" noRot="1" noChangeAspect="1"/>
-          </p:cNvSpPr>
-          <p:nvPr>
-            <p:ph type="sldImg"/>
-          </p:nvPr>
-        </p:nvSpPr>
-        <p:spPr/>
-      </p:sp>
-      <p:sp>
-        <p:nvSpPr>
-          <p:cNvPr id="3" name="Notes Placeholder 2"/>
-          <p:cNvSpPr>
-            <a:spLocks noGrp="1"/>
-          </p:cNvSpPr>
-          <p:nvPr>
-            <p:ph type="body" idx="1"/>
-          </p:nvPr>
-        </p:nvSpPr>
-        <p:spPr/>
-        <p:txBody>
-          <a:bodyPr/>
-          <a:lstStyle/>
-          <a:p>
-            <a:r>
-              <a:rPr lang="en-US" dirty="0"/>
-              <a:t>Backup for the live demo, about 2 minutes. Left: the default view, with all 113 areas coloured by income and incident rate, and every chart showing the whole city. Right: the same dashboard after one click on the legend square for lower-income, high incident-rate areas. The map highlights those 16 areas, mostly in the east. The details panel summarises the group: about 14% of Calgary’s population, a median income range of roughly $29,000 to $42,000, and a local incident rate about 2.5 times the city average. The KPIs, heatmap and month chart all filter to those areas, so you can see their busiest hour moves to 4 to 5 PM. If there’s time, open the live report from the link and click an individual area.</a:t>
+              <a:t>[9:45 – 10:00] Thanks for listening. I’m happy to take questions, or to go back into the dashboard to look at any area you’re curious about.</a:t>
             </a:r>
           </a:p>
         </p:txBody>
@@ -1014,7 +668,7 @@
                 <a:tabLst/>
                 <a:defRPr/>
               </a:pPr>
-              <a:t>6</a:t>
+              <a:t>10</a:t>
             </a:fld>
             <a:endParaRPr kumimoji="0" lang="en-US" sz="1800" b="0" i="0" u="none" strike="noStrike" kern="1200" cap="none" spc="0" normalizeH="0" baseline="0" noProof="0">
               <a:ln>
@@ -1030,6 +684,441 @@
               <a:ea typeface="+mn-ea"/>
               <a:cs typeface="+mn-cs"/>
             </a:endParaRPr>
+          </a:p>
+        </p:txBody>
+      </p:sp>
+    </p:spTree>
+    <p:extLst>
+      <p:ext uri="{BB962C8B-B14F-4D97-AF65-F5344CB8AC3E}">
+        <p14:creationId xmlns:p14="http://schemas.microsoft.com/office/powerpoint/2010/main" val="1024086991"/>
+      </p:ext>
+    </p:extLst>
+  </p:cSld>
+  <p:clrMapOvr>
+    <a:masterClrMapping/>
+  </p:clrMapOvr>
+</p:notes>
+</file>
+
+<file path=ppt/notesSlides/notesSlide2.xml><?xml version="1.0" encoding="utf-8"?>
+<p:notes xmlns:a="http://schemas.openxmlformats.org/drawingml/2006/main" xmlns:r="http://schemas.openxmlformats.org/officeDocument/2006/relationships" xmlns:p="http://schemas.openxmlformats.org/presentationml/2006/main">
+  <p:cSld>
+    <p:spTree>
+      <p:nvGrpSpPr>
+        <p:cNvPr id="1" name=""/>
+        <p:cNvGrpSpPr/>
+        <p:nvPr/>
+      </p:nvGrpSpPr>
+      <p:grpSpPr>
+        <a:xfrm>
+          <a:off x="0" y="0"/>
+          <a:ext cx="0" cy="0"/>
+          <a:chOff x="0" y="0"/>
+          <a:chExt cx="0" cy="0"/>
+        </a:xfrm>
+      </p:grpSpPr>
+      <p:sp>
+        <p:nvSpPr>
+          <p:cNvPr id="2" name="Slide Image Placeholder 1"/>
+          <p:cNvSpPr>
+            <a:spLocks noGrp="1" noRot="1" noChangeAspect="1"/>
+          </p:cNvSpPr>
+          <p:nvPr>
+            <p:ph type="sldImg"/>
+          </p:nvPr>
+        </p:nvSpPr>
+        <p:spPr/>
+      </p:sp>
+      <p:sp>
+        <p:nvSpPr>
+          <p:cNvPr id="3" name="Notes Placeholder 2"/>
+          <p:cNvSpPr>
+            <a:spLocks noGrp="1"/>
+          </p:cNvSpPr>
+          <p:nvPr>
+            <p:ph type="body" idx="1"/>
+          </p:nvPr>
+        </p:nvSpPr>
+        <p:spPr/>
+        <p:txBody>
+          <a:bodyPr/>
+          <a:lstStyle/>
+          <a:p>
+            <a:r>
+              <a:rPr lang="en-US" dirty="0"/>
+              <a:t>Traffic incidents aren’t random. They cluster on certain roads, at certain times, and in certain parts of the city. My project uses City of Calgary open data to ask whether neighbourhood income and related conditions, like renting, low income and how people commute, line up with where incidents happen. The study area is the whole city, split into 113 community service areas. I use nine complete years, 2017 to 2025, and the result is an interactive Power BI dashboard.</a:t>
+            </a:r>
+          </a:p>
+        </p:txBody>
+      </p:sp>
+      <p:sp>
+        <p:nvSpPr>
+          <p:cNvPr id="4" name="Slide Number Placeholder 3"/>
+          <p:cNvSpPr>
+            <a:spLocks noGrp="1"/>
+          </p:cNvSpPr>
+          <p:nvPr>
+            <p:ph type="sldNum" sz="quarter" idx="10"/>
+          </p:nvPr>
+        </p:nvSpPr>
+        <p:spPr/>
+        <p:txBody>
+          <a:bodyPr/>
+          <a:lstStyle/>
+          <a:p>
+            <a:fld id="{F7021451-1387-4CA6-816F-3879F97B5CBC}" type="slidenum">
+              <a:rPr lang="en-US"/>
+              <a:t>2</a:t>
+            </a:fld>
+            <a:endParaRPr lang="en-US"/>
+          </a:p>
+        </p:txBody>
+      </p:sp>
+    </p:spTree>
+    <p:extLst>
+      <p:ext uri="{BB962C8B-B14F-4D97-AF65-F5344CB8AC3E}">
+        <p14:creationId xmlns:p14="http://schemas.microsoft.com/office/powerpoint/2010/main" val="1024086991"/>
+      </p:ext>
+    </p:extLst>
+  </p:cSld>
+  <p:clrMapOvr>
+    <a:masterClrMapping/>
+  </p:clrMapOvr>
+</p:notes>
+</file>
+
+<file path=ppt/notesSlides/notesSlide3.xml><?xml version="1.0" encoding="utf-8"?>
+<p:notes xmlns:a="http://schemas.openxmlformats.org/drawingml/2006/main" xmlns:r="http://schemas.openxmlformats.org/officeDocument/2006/relationships" xmlns:p="http://schemas.openxmlformats.org/presentationml/2006/main">
+  <p:cSld>
+    <p:spTree>
+      <p:nvGrpSpPr>
+        <p:cNvPr id="1" name=""/>
+        <p:cNvGrpSpPr/>
+        <p:nvPr/>
+      </p:nvGrpSpPr>
+      <p:grpSpPr>
+        <a:xfrm>
+          <a:off x="0" y="0"/>
+          <a:ext cx="0" cy="0"/>
+          <a:chOff x="0" y="0"/>
+          <a:chExt cx="0" cy="0"/>
+        </a:xfrm>
+      </p:grpSpPr>
+      <p:sp>
+        <p:nvSpPr>
+          <p:cNvPr id="2" name="Slide Image Placeholder 1"/>
+          <p:cNvSpPr>
+            <a:spLocks noGrp="1" noRot="1" noChangeAspect="1"/>
+          </p:cNvSpPr>
+          <p:nvPr>
+            <p:ph type="sldImg"/>
+          </p:nvPr>
+        </p:nvSpPr>
+        <p:spPr/>
+      </p:sp>
+      <p:sp>
+        <p:nvSpPr>
+          <p:cNvPr id="3" name="Notes Placeholder 2"/>
+          <p:cNvSpPr>
+            <a:spLocks noGrp="1"/>
+          </p:cNvSpPr>
+          <p:nvPr>
+            <p:ph type="body" idx="1"/>
+          </p:nvPr>
+        </p:nvSpPr>
+        <p:spPr/>
+        <p:txBody>
+          <a:bodyPr/>
+          <a:lstStyle/>
+          <a:p>
+            <a:r>
+              <a:rPr lang="en-US" dirty="0"/>
+              <a:t>I have three questions. First, where: once we account for how many people live in an area, where do incidents concentrate, and does that match neighbourhood income? Second, who: beyond income, which neighbourhood traits, like renting, low income or commuting by car, go along with higher incident rates? Third, when: what times of day, days of the week and months of the year see the most incidents? Each question maps to a part of the dashboard.</a:t>
+            </a:r>
+          </a:p>
+        </p:txBody>
+      </p:sp>
+      <p:sp>
+        <p:nvSpPr>
+          <p:cNvPr id="4" name="Slide Number Placeholder 3"/>
+          <p:cNvSpPr>
+            <a:spLocks noGrp="1"/>
+          </p:cNvSpPr>
+          <p:nvPr>
+            <p:ph type="sldNum" sz="quarter" idx="10"/>
+          </p:nvPr>
+        </p:nvSpPr>
+        <p:spPr/>
+        <p:txBody>
+          <a:bodyPr/>
+          <a:lstStyle/>
+          <a:p>
+            <a:fld id="{F7021451-1387-4CA6-816F-3879F97B5CBC}" type="slidenum">
+              <a:rPr lang="en-US"/>
+              <a:t>3</a:t>
+            </a:fld>
+            <a:endParaRPr lang="en-US"/>
+          </a:p>
+        </p:txBody>
+      </p:sp>
+    </p:spTree>
+    <p:extLst>
+      <p:ext uri="{BB962C8B-B14F-4D97-AF65-F5344CB8AC3E}">
+        <p14:creationId xmlns:p14="http://schemas.microsoft.com/office/powerpoint/2010/main" val="1024086991"/>
+      </p:ext>
+    </p:extLst>
+  </p:cSld>
+  <p:clrMapOvr>
+    <a:masterClrMapping/>
+  </p:clrMapOvr>
+</p:notes>
+</file>
+
+<file path=ppt/notesSlides/notesSlide4.xml><?xml version="1.0" encoding="utf-8"?>
+<p:notes xmlns:a="http://schemas.openxmlformats.org/drawingml/2006/main" xmlns:r="http://schemas.openxmlformats.org/officeDocument/2006/relationships" xmlns:p="http://schemas.openxmlformats.org/presentationml/2006/main">
+  <p:cSld>
+    <p:spTree>
+      <p:nvGrpSpPr>
+        <p:cNvPr id="1" name=""/>
+        <p:cNvGrpSpPr/>
+        <p:nvPr/>
+      </p:nvGrpSpPr>
+      <p:grpSpPr>
+        <a:xfrm>
+          <a:off x="0" y="0"/>
+          <a:ext cx="0" cy="0"/>
+          <a:chOff x="0" y="0"/>
+          <a:chExt cx="0" cy="0"/>
+        </a:xfrm>
+      </p:grpSpPr>
+      <p:sp>
+        <p:nvSpPr>
+          <p:cNvPr id="2" name="Slide Image Placeholder 1"/>
+          <p:cNvSpPr>
+            <a:spLocks noGrp="1" noRot="1" noChangeAspect="1"/>
+          </p:cNvSpPr>
+          <p:nvPr>
+            <p:ph type="sldImg"/>
+          </p:nvPr>
+        </p:nvSpPr>
+        <p:spPr/>
+      </p:sp>
+      <p:sp>
+        <p:nvSpPr>
+          <p:cNvPr id="3" name="Notes Placeholder 2"/>
+          <p:cNvSpPr>
+            <a:spLocks noGrp="1"/>
+          </p:cNvSpPr>
+          <p:nvPr>
+            <p:ph type="body" idx="1"/>
+          </p:nvPr>
+        </p:nvSpPr>
+        <p:spPr/>
+        <p:txBody>
+          <a:bodyPr/>
+          <a:lstStyle/>
+          <a:p>
+            <a:r>
+              <a:rPr lang="en-US" dirty="0"/>
+              <a:t>All three datasets come from the City of Calgary’s open data portal, and all are obtained. Traffic Incidents is the core: 65,138 records, each with a location, description and timestamp. The Equity Index file covers 113 community service areas with population, median income and 16 other census measures, plus their boundaries. Community District Boundaries adds 313 communities with their land-use class, which lets me separate residential areas from industrial ones.</a:t>
+            </a:r>
+          </a:p>
+        </p:txBody>
+      </p:sp>
+      <p:sp>
+        <p:nvSpPr>
+          <p:cNvPr id="4" name="Slide Number Placeholder 3"/>
+          <p:cNvSpPr>
+            <a:spLocks noGrp="1"/>
+          </p:cNvSpPr>
+          <p:nvPr>
+            <p:ph type="sldNum" sz="quarter" idx="10"/>
+          </p:nvPr>
+        </p:nvSpPr>
+        <p:spPr/>
+        <p:txBody>
+          <a:bodyPr/>
+          <a:lstStyle/>
+          <a:p>
+            <a:fld id="{F7021451-1387-4CA6-816F-3879F97B5CBC}" type="slidenum">
+              <a:rPr lang="en-US"/>
+              <a:t>4</a:t>
+            </a:fld>
+            <a:endParaRPr lang="en-US"/>
+          </a:p>
+        </p:txBody>
+      </p:sp>
+    </p:spTree>
+    <p:extLst>
+      <p:ext uri="{BB962C8B-B14F-4D97-AF65-F5344CB8AC3E}">
+        <p14:creationId xmlns:p14="http://schemas.microsoft.com/office/powerpoint/2010/main" val="1024086991"/>
+      </p:ext>
+    </p:extLst>
+  </p:cSld>
+  <p:clrMapOvr>
+    <a:masterClrMapping/>
+  </p:clrMapOvr>
+</p:notes>
+</file>
+
+<file path=ppt/notesSlides/notesSlide5.xml><?xml version="1.0" encoding="utf-8"?>
+<p:notes xmlns:a="http://schemas.openxmlformats.org/drawingml/2006/main" xmlns:r="http://schemas.openxmlformats.org/officeDocument/2006/relationships" xmlns:p="http://schemas.openxmlformats.org/presentationml/2006/main">
+  <p:cSld>
+    <p:spTree>
+      <p:nvGrpSpPr>
+        <p:cNvPr id="1" name=""/>
+        <p:cNvGrpSpPr/>
+        <p:nvPr/>
+      </p:nvGrpSpPr>
+      <p:grpSpPr>
+        <a:xfrm>
+          <a:off x="0" y="0"/>
+          <a:ext cx="0" cy="0"/>
+          <a:chOff x="0" y="0"/>
+          <a:chExt cx="0" cy="0"/>
+        </a:xfrm>
+      </p:grpSpPr>
+      <p:sp>
+        <p:nvSpPr>
+          <p:cNvPr id="2" name="Slide Image Placeholder 1"/>
+          <p:cNvSpPr>
+            <a:spLocks noGrp="1" noRot="1" noChangeAspect="1"/>
+          </p:cNvSpPr>
+          <p:nvPr>
+            <p:ph type="sldImg"/>
+          </p:nvPr>
+        </p:nvSpPr>
+        <p:spPr/>
+      </p:sp>
+      <p:sp>
+        <p:nvSpPr>
+          <p:cNvPr id="3" name="Notes Placeholder 2"/>
+          <p:cNvSpPr>
+            <a:spLocks noGrp="1"/>
+          </p:cNvSpPr>
+          <p:nvPr>
+            <p:ph type="body" idx="1"/>
+          </p:nvPr>
+        </p:nvSpPr>
+        <p:spPr/>
+        <p:txBody>
+          <a:bodyPr/>
+          <a:lstStyle/>
+          <a:p>
+            <a:r>
+              <a:rPr lang="en-US" dirty="0"/>
+              <a:t>Here’s how I prepared the data. First, each incident only had a map point, so I used Python to read every area’s boundary outline and check which outline contains each point. This is called a point-in-polygon test. 785 incidents fall outside every area and stay unassigned. Second, the census file had one row per measure, so I reshaped it to one row per area and cleaned up the number formats. Third, I set each incident’s type from keywords in its description and flagged highway incidents by street name. Fourth, I filtered to the nine complete years, which leaves 58,536 incidents. Fifth, to compare areas fairly, I divided each area’s incidents by its population and the nine years, using only local roads in residential communities. Finally, I wrote DAX measures that power the dashboard: each selection’s rate compared with the city average, the busiest hour, a monthly rate that adjusts for missing data, and the correlations between neighbourhood traits and incident rates.</a:t>
+            </a:r>
+          </a:p>
+        </p:txBody>
+      </p:sp>
+      <p:sp>
+        <p:nvSpPr>
+          <p:cNvPr id="4" name="Slide Number Placeholder 3"/>
+          <p:cNvSpPr>
+            <a:spLocks noGrp="1"/>
+          </p:cNvSpPr>
+          <p:nvPr>
+            <p:ph type="sldNum" sz="quarter" idx="10"/>
+          </p:nvPr>
+        </p:nvSpPr>
+        <p:spPr/>
+        <p:txBody>
+          <a:bodyPr/>
+          <a:lstStyle/>
+          <a:p>
+            <a:fld id="{F7021451-1387-4CA6-816F-3879F97B5CBC}" type="slidenum">
+              <a:rPr lang="en-US"/>
+              <a:t>5</a:t>
+            </a:fld>
+            <a:endParaRPr lang="en-US"/>
+          </a:p>
+        </p:txBody>
+      </p:sp>
+    </p:spTree>
+    <p:extLst>
+      <p:ext uri="{BB962C8B-B14F-4D97-AF65-F5344CB8AC3E}">
+        <p14:creationId xmlns:p14="http://schemas.microsoft.com/office/powerpoint/2010/main" val="1024086991"/>
+      </p:ext>
+    </p:extLst>
+  </p:cSld>
+  <p:clrMapOvr>
+    <a:masterClrMapping/>
+  </p:clrMapOvr>
+</p:notes>
+</file>
+
+<file path=ppt/notesSlides/notesSlide6.xml><?xml version="1.0" encoding="utf-8"?>
+<p:notes xmlns:a="http://schemas.openxmlformats.org/drawingml/2006/main" xmlns:r="http://schemas.openxmlformats.org/officeDocument/2006/relationships" xmlns:p="http://schemas.openxmlformats.org/presentationml/2006/main">
+  <p:cSld>
+    <p:spTree>
+      <p:nvGrpSpPr>
+        <p:cNvPr id="1" name=""/>
+        <p:cNvGrpSpPr/>
+        <p:nvPr/>
+      </p:nvGrpSpPr>
+      <p:grpSpPr>
+        <a:xfrm>
+          <a:off x="0" y="0"/>
+          <a:ext cx="0" cy="0"/>
+          <a:chOff x="0" y="0"/>
+          <a:chExt cx="0" cy="0"/>
+        </a:xfrm>
+      </p:grpSpPr>
+      <p:sp>
+        <p:nvSpPr>
+          <p:cNvPr id="2" name="Slide Image Placeholder 1"/>
+          <p:cNvSpPr>
+            <a:spLocks noGrp="1" noRot="1" noChangeAspect="1"/>
+          </p:cNvSpPr>
+          <p:nvPr>
+            <p:ph type="sldImg"/>
+          </p:nvPr>
+        </p:nvSpPr>
+        <p:spPr/>
+      </p:sp>
+      <p:sp>
+        <p:nvSpPr>
+          <p:cNvPr id="3" name="Notes Placeholder 2"/>
+          <p:cNvSpPr>
+            <a:spLocks noGrp="1"/>
+          </p:cNvSpPr>
+          <p:nvPr>
+            <p:ph type="body" idx="1"/>
+          </p:nvPr>
+        </p:nvSpPr>
+        <p:spPr/>
+        <p:txBody>
+          <a:bodyPr/>
+          <a:lstStyle/>
+          <a:p>
+            <a:r>
+              <a:rPr lang="en-US" dirty="0"/>
+              <a:t>Each card shows what the data looked like before and after one step. First, I kept only full years: the raw file has 65,138 incidents from December 2016 to 2026, and keeping 2017 to 2025 leaves 58,536. Second, each incident only had a map point, so I used GeoPandas in Python to check which area outline each point falls inside. 639 fall outside every area, and the same outlines became the Shape Map. Third, I turned the free-text description into five incident types using keywords, which powers the incident type filter, and flagged highways like Deerfoot and Glenmore by street name, so the map’s rates only count local roads. Fourth, the census file had one row for every area and trait, 2,091 rows, so I reshaped it to one row per area, 113 rows, with each trait as its own column. Fifth, every incident carries both its community and its area, which links the 307 communities to the 113 areas, and I then rated each area by incidents per 1,000 residents a year. Finally, DAX measures turn those rows into the numbers on the dashboard, like rate versus the city average and the busiest hour, and they update with every click.</a:t>
+            </a:r>
+          </a:p>
+        </p:txBody>
+      </p:sp>
+      <p:sp>
+        <p:nvSpPr>
+          <p:cNvPr id="4" name="Slide Number Placeholder 3"/>
+          <p:cNvSpPr>
+            <a:spLocks noGrp="1"/>
+          </p:cNvSpPr>
+          <p:nvPr>
+            <p:ph type="sldNum" sz="quarter" idx="10"/>
+          </p:nvPr>
+        </p:nvSpPr>
+        <p:spPr/>
+        <p:txBody>
+          <a:bodyPr/>
+          <a:lstStyle/>
+          <a:p>
+            <a:fld id="{F7021451-1387-4CA6-816F-3879F97B5CBC}" type="slidenum">
+              <a:rPr lang="en-US"/>
+              <a:t>6</a:t>
+            </a:fld>
+            <a:endParaRPr lang="en-US"/>
           </a:p>
         </p:txBody>
       </p:sp>
@@ -1092,7 +1181,7 @@
           <a:p>
             <a:r>
               <a:rPr lang="en-US" dirty="0"/>
-              <a:t>Here’s what the map itself shows. Each area is coloured by two things at once: its median income and its local incident rate. Two groups stand out, both with 16 areas each. Sixteen lower-income areas have high incident rates, shown in pink, and sixteen higher-income areas have low incident rates, shown in blue. They’re the two largest groups on the map, and mirror images of each other. Geographically, the pink areas line the east side of the city, while the blue areas fill the west and south. The exception is the city centre: 11 higher-income areas still have high rates, shown in dark purple, mostly downtown and in the inner city, where commuters and through-traffic add incidents that resident-based rates don’t account for.</a:t>
+              <a:t>Backup for the live demo, about 2 minutes. Left: the default view, with all 113 areas coloured by income and incident rate, and every chart showing the whole city. Right: the same dashboard after one click on the legend square for lower-income, high incident-rate areas. The map highlights those 16 areas, mostly in the east. The details panel summarises the group: about 14% of Calgary’s population, a median income range of roughly $29,000 to $42,000, and a local incident rate about 2.5 times the city average. The KPIs, heatmap and month chart all filter to those areas, so you can see their busiest hour moves to 4 to 5 PM. If there’s time, open the live report from the link and click an individual area.</a:t>
             </a:r>
           </a:p>
         </p:txBody>
@@ -1239,94 +1328,7 @@
           <a:p>
             <a:r>
               <a:rPr lang="en-US" dirty="0"/>
-              <a:t>The time patterns are clear. The heatmap shows incidents concentrate on weekday afternoons: about a quarter of all incidents happen between 3 and 6 PM, and 5 to 6 PM is the single busiest hour, which lines up with the evening commute. Weekends are much quieter; Sunday has about half as many incidents as Wednesday. By month, the rate climbs through fall and peaks in November and December, at about 1.6 times April’s rate, which points to winter driving conditions and shorter daylight.</a:t>
-            </a:r>
-          </a:p>
-        </p:txBody>
-      </p:sp>
-      <p:sp>
-        <p:nvSpPr>
-          <p:cNvPr id="4" name="Slide Number Placeholder 3"/>
-          <p:cNvSpPr>
-            <a:spLocks noGrp="1"/>
-          </p:cNvSpPr>
-          <p:nvPr>
-            <p:ph type="sldNum" sz="quarter" idx="10"/>
-          </p:nvPr>
-        </p:nvSpPr>
-        <p:spPr/>
-        <p:txBody>
-          <a:bodyPr/>
-          <a:lstStyle/>
-          <a:p>
-            <a:fld id="{F7021451-1387-4CA6-816F-3879F97B5CBC}" type="slidenum">
-              <a:rPr lang="en-US"/>
-              <a:t>8</a:t>
-            </a:fld>
-            <a:endParaRPr lang="en-US"/>
-          </a:p>
-        </p:txBody>
-      </p:sp>
-    </p:spTree>
-    <p:extLst>
-      <p:ext uri="{BB962C8B-B14F-4D97-AF65-F5344CB8AC3E}">
-        <p14:creationId xmlns:p14="http://schemas.microsoft.com/office/powerpoint/2010/main" val="1024086991"/>
-      </p:ext>
-    </p:extLst>
-  </p:cSld>
-  <p:clrMapOvr>
-    <a:masterClrMapping/>
-  </p:clrMapOvr>
-</p:notes>
-</file>
-
-<file path=ppt/notesSlides/notesSlide9.xml><?xml version="1.0" encoding="utf-8"?>
-<p:notes xmlns:a="http://schemas.openxmlformats.org/drawingml/2006/main" xmlns:r="http://schemas.openxmlformats.org/officeDocument/2006/relationships" xmlns:p="http://schemas.openxmlformats.org/presentationml/2006/main">
-  <p:cSld>
-    <p:spTree>
-      <p:nvGrpSpPr>
-        <p:cNvPr id="1" name=""/>
-        <p:cNvGrpSpPr/>
-        <p:nvPr/>
-      </p:nvGrpSpPr>
-      <p:grpSpPr>
-        <a:xfrm>
-          <a:off x="0" y="0"/>
-          <a:ext cx="0" cy="0"/>
-          <a:chOff x="0" y="0"/>
-          <a:chExt cx="0" cy="0"/>
-        </a:xfrm>
-      </p:grpSpPr>
-      <p:sp>
-        <p:nvSpPr>
-          <p:cNvPr id="2" name="Slide Image Placeholder 1"/>
-          <p:cNvSpPr>
-            <a:spLocks noGrp="1" noRot="1" noChangeAspect="1"/>
-          </p:cNvSpPr>
-          <p:nvPr>
-            <p:ph type="sldImg"/>
-          </p:nvPr>
-        </p:nvSpPr>
-        <p:spPr/>
-      </p:sp>
-      <p:sp>
-        <p:nvSpPr>
-          <p:cNvPr id="3" name="Notes Placeholder 2"/>
-          <p:cNvSpPr>
-            <a:spLocks noGrp="1"/>
-          </p:cNvSpPr>
-          <p:nvPr>
-            <p:ph type="body" idx="1"/>
-          </p:nvPr>
-        </p:nvSpPr>
-        <p:spPr/>
-        <p:txBody>
-          <a:bodyPr/>
-          <a:lstStyle/>
-          <a:p>
-            <a:r>
-              <a:rPr lang="en-US" dirty="0"/>
-              <a:t>[9:45 – 10:00] Thanks for listening. I’m happy to take questions, or to go back into the dashboard to look at any area you’re curious about.</a:t>
+              <a:t>Here’s what the map itself shows. Each area is coloured by two things at once: its median income and its local incident rate. Two groups stand out, both with 16 areas each. Sixteen lower-income areas have high incident rates, shown in pink, and sixteen higher-income areas have low incident rates, shown in blue. They’re the two largest groups on the map, and mirror images of each other. Geographically, the pink areas line the east side of the city, while the blue areas fill the west and south. The exception is the city centre: 11 higher-income areas still have high rates, shown in dark purple, mostly downtown and in the inner city, where commuters and through-traffic add incidents that resident-based rates don’t account for.</a:t>
             </a:r>
           </a:p>
         </p:txBody>
@@ -1395,7 +1397,7 @@
                 <a:tabLst/>
                 <a:defRPr/>
               </a:pPr>
-              <a:t>9</a:t>
+              <a:t>8</a:t>
             </a:fld>
             <a:endParaRPr kumimoji="0" lang="en-US" sz="1800" b="0" i="0" u="none" strike="noStrike" kern="1200" cap="none" spc="0" normalizeH="0" baseline="0" noProof="0">
               <a:ln>
@@ -1411,6 +1413,93 @@
               <a:ea typeface="+mn-ea"/>
               <a:cs typeface="+mn-cs"/>
             </a:endParaRPr>
+          </a:p>
+        </p:txBody>
+      </p:sp>
+    </p:spTree>
+    <p:extLst>
+      <p:ext uri="{BB962C8B-B14F-4D97-AF65-F5344CB8AC3E}">
+        <p14:creationId xmlns:p14="http://schemas.microsoft.com/office/powerpoint/2010/main" val="1024086991"/>
+      </p:ext>
+    </p:extLst>
+  </p:cSld>
+  <p:clrMapOvr>
+    <a:masterClrMapping/>
+  </p:clrMapOvr>
+</p:notes>
+</file>
+
+<file path=ppt/notesSlides/notesSlide9.xml><?xml version="1.0" encoding="utf-8"?>
+<p:notes xmlns:a="http://schemas.openxmlformats.org/drawingml/2006/main" xmlns:r="http://schemas.openxmlformats.org/officeDocument/2006/relationships" xmlns:p="http://schemas.openxmlformats.org/presentationml/2006/main">
+  <p:cSld>
+    <p:spTree>
+      <p:nvGrpSpPr>
+        <p:cNvPr id="1" name=""/>
+        <p:cNvGrpSpPr/>
+        <p:nvPr/>
+      </p:nvGrpSpPr>
+      <p:grpSpPr>
+        <a:xfrm>
+          <a:off x="0" y="0"/>
+          <a:ext cx="0" cy="0"/>
+          <a:chOff x="0" y="0"/>
+          <a:chExt cx="0" cy="0"/>
+        </a:xfrm>
+      </p:grpSpPr>
+      <p:sp>
+        <p:nvSpPr>
+          <p:cNvPr id="2" name="Slide Image Placeholder 1"/>
+          <p:cNvSpPr>
+            <a:spLocks noGrp="1" noRot="1" noChangeAspect="1"/>
+          </p:cNvSpPr>
+          <p:nvPr>
+            <p:ph type="sldImg"/>
+          </p:nvPr>
+        </p:nvSpPr>
+        <p:spPr/>
+      </p:sp>
+      <p:sp>
+        <p:nvSpPr>
+          <p:cNvPr id="3" name="Notes Placeholder 2"/>
+          <p:cNvSpPr>
+            <a:spLocks noGrp="1"/>
+          </p:cNvSpPr>
+          <p:nvPr>
+            <p:ph type="body" idx="1"/>
+          </p:nvPr>
+        </p:nvSpPr>
+        <p:spPr/>
+        <p:txBody>
+          <a:bodyPr/>
+          <a:lstStyle/>
+          <a:p>
+            <a:r>
+              <a:rPr lang="en-US" dirty="0"/>
+              <a:t>The time patterns are clear. The heatmap shows incidents concentrate on weekday afternoons: about a quarter of all incidents happen between 3 and 6 PM, and 5 to 6 PM is the single busiest hour, which lines up with the evening commute. Weekends are much quieter; Sunday has about half as many incidents as Wednesday. By month, the rate climbs through fall and peaks in November and December, at about 1.6 times April’s rate, which points to winter driving conditions and shorter daylight.</a:t>
+            </a:r>
+          </a:p>
+        </p:txBody>
+      </p:sp>
+      <p:sp>
+        <p:nvSpPr>
+          <p:cNvPr id="4" name="Slide Number Placeholder 3"/>
+          <p:cNvSpPr>
+            <a:spLocks noGrp="1"/>
+          </p:cNvSpPr>
+          <p:nvPr>
+            <p:ph type="sldNum" sz="quarter" idx="10"/>
+          </p:nvPr>
+        </p:nvSpPr>
+        <p:spPr/>
+        <p:txBody>
+          <a:bodyPr/>
+          <a:lstStyle/>
+          <a:p>
+            <a:fld id="{F7021451-1387-4CA6-816F-3879F97B5CBC}" type="slidenum">
+              <a:rPr lang="en-US"/>
+              <a:t>9</a:t>
+            </a:fld>
+            <a:endParaRPr lang="en-US"/>
           </a:p>
         </p:txBody>
       </p:sp>
@@ -1727,6 +1816,144 @@
     <p:bg>
       <p:bgPr>
         <a:solidFill>
+          <a:srgbClr val="F6F4F0"/>
+        </a:solidFill>
+        <a:effectLst/>
+      </p:bgPr>
+    </p:bg>
+    <p:spTree>
+      <p:nvGrpSpPr>
+        <p:cNvPr id="1" name=""/>
+        <p:cNvGrpSpPr/>
+        <p:nvPr/>
+      </p:nvGrpSpPr>
+      <p:grpSpPr>
+        <a:xfrm>
+          <a:off x="0" y="0"/>
+          <a:ext cx="0" cy="0"/>
+          <a:chOff x="0" y="0"/>
+          <a:chExt cx="0" cy="0"/>
+        </a:xfrm>
+      </p:grpSpPr>
+      <p:sp>
+        <p:nvSpPr>
+          <p:cNvPr id="2" name="Title Placeholder 1"/>
+          <p:cNvSpPr>
+            <a:spLocks noGrp="1"/>
+          </p:cNvSpPr>
+          <p:nvPr>
+            <p:ph type="title"/>
+          </p:nvPr>
+        </p:nvSpPr>
+        <p:spPr>
+          <a:xfrm>
+            <a:off x="812800" y="812800"/>
+            <a:ext cx="10566400" cy="467320"/>
+          </a:xfrm>
+          <a:prstGeom prst="rect">
+            <a:avLst/>
+          </a:prstGeom>
+          <a:noFill/>
+          <a:ln/>
+        </p:spPr>
+        <p:txBody>
+          <a:bodyPr wrap="square" lIns="0" tIns="0" rIns="0" bIns="0" rtlCol="0" anchor="t"/>
+          <a:lstStyle>
+            <a:lvl1pPr marL="0" indent="0" algn="l">
+              <a:lnSpc>
+                <a:spcPct val="115000"/>
+              </a:lnSpc>
+              <a:buNone/>
+              <a:defRPr lang="en-US" sz="3200" dirty="0">
+                <a:solidFill>
+                  <a:srgbClr val="2B2B30"/>
+                </a:solidFill>
+                <a:latin typeface="Libre Baskerville" pitchFamily="34" charset="0"/>
+                <a:ea typeface="Libre Baskerville" pitchFamily="34" charset="-122"/>
+                <a:cs typeface="Libre Baskerville" pitchFamily="34" charset="-120"/>
+              </a:defRPr>
+            </a:lvl1pPr>
+          </a:lstStyle>
+          <a:p>
+            <a:pPr marL="0" indent="0" algn="l">
+              <a:lnSpc>
+                <a:spcPct val="115000"/>
+              </a:lnSpc>
+              <a:buNone/>
+            </a:pPr>
+            <a:endParaRPr lang="en-US" sz="3200" dirty="0"/>
+          </a:p>
+        </p:txBody>
+      </p:sp>
+      <p:sp>
+        <p:nvSpPr>
+          <p:cNvPr id="3" name="Text Placeholder 2"/>
+          <p:cNvSpPr>
+            <a:spLocks noGrp="1"/>
+          </p:cNvSpPr>
+          <p:nvPr>
+            <p:ph type="body" idx="101"/>
+          </p:nvPr>
+        </p:nvSpPr>
+        <p:spPr>
+          <a:xfrm>
+            <a:off x="812800" y="1584920"/>
+            <a:ext cx="10566400" cy="4460280"/>
+          </a:xfrm>
+          <a:prstGeom prst="rect">
+            <a:avLst/>
+          </a:prstGeom>
+          <a:noFill/>
+          <a:ln/>
+        </p:spPr>
+        <p:txBody>
+          <a:bodyPr wrap="square" lIns="0" tIns="0" rIns="0" bIns="0" rtlCol="0" anchor="t"/>
+          <a:lstStyle>
+            <a:lvl1pPr marL="0" indent="0" algn="l">
+              <a:lnSpc>
+                <a:spcPct val="140000"/>
+              </a:lnSpc>
+              <a:buNone/>
+              <a:defRPr lang="en-US" sz="1600" dirty="0">
+                <a:solidFill>
+                  <a:srgbClr val="2B2B30"/>
+                </a:solidFill>
+                <a:latin typeface="Public Sans" pitchFamily="34" charset="0"/>
+                <a:ea typeface="Public Sans" pitchFamily="34" charset="-122"/>
+                <a:cs typeface="Public Sans" pitchFamily="34" charset="-120"/>
+              </a:defRPr>
+            </a:lvl1pPr>
+          </a:lstStyle>
+          <a:p>
+            <a:pPr marL="0" indent="0" algn="l">
+              <a:lnSpc>
+                <a:spcPct val="140000"/>
+              </a:lnSpc>
+              <a:buNone/>
+            </a:pPr>
+            <a:endParaRPr lang="en-US" sz="1600" dirty="0"/>
+          </a:p>
+        </p:txBody>
+      </p:sp>
+    </p:spTree>
+    <p:extLst>
+      <p:ext uri="{BB962C8B-B14F-4D97-AF65-F5344CB8AC3E}">
+        <p14:creationId xmlns:p14="http://schemas.microsoft.com/office/powerpoint/2010/main" val="1742836407"/>
+      </p:ext>
+    </p:extLst>
+  </p:cSld>
+  <p:clrMapOvr>
+    <a:masterClrMapping/>
+  </p:clrMapOvr>
+</p:sldLayout>
+</file>
+
+<file path=ppt/slideLayouts/slideLayout7.xml><?xml version="1.0" encoding="utf-8"?>
+<p:sldLayout xmlns:a="http://schemas.openxmlformats.org/drawingml/2006/main" xmlns:r="http://schemas.openxmlformats.org/officeDocument/2006/relationships" xmlns:p="http://schemas.openxmlformats.org/presentationml/2006/main">
+  <p:cSld name="Title and body">
+    <p:bg>
+      <p:bgPr>
+        <a:solidFill>
           <a:srgbClr val="F4EEE3"/>
         </a:solidFill>
         <a:effectLst/>
@@ -1890,6 +2117,7 @@
     <p:sldLayoutId id="2147483651" r:id="rId3"/>
     <p:sldLayoutId id="2147483652" r:id="rId4"/>
     <p:sldLayoutId id="2147483653" r:id="rId5"/>
+    <p:sldLayoutId id="2147483656" r:id="rId6"/>
   </p:sldLayoutIdLst>
   <p:hf sldNum="0" hdr="0" ftr="0" dt="0"/>
   <p:txStyles>
@@ -3045,6 +3273,730 @@
               <a:t>, 2026</a:t>
             </a:r>
             <a:endParaRPr lang="en-US" sz="1400" dirty="0"/>
+          </a:p>
+        </p:txBody>
+      </p:sp>
+    </p:spTree>
+  </p:cSld>
+  <p:clrMapOvr>
+    <a:masterClrMapping/>
+  </p:clrMapOvr>
+</p:sld>
+</file>
+
+<file path=ppt/slides/slide10.xml><?xml version="1.0" encoding="utf-8"?>
+<p:sld xmlns:a="http://schemas.openxmlformats.org/drawingml/2006/main" xmlns:r="http://schemas.openxmlformats.org/officeDocument/2006/relationships" xmlns:p="http://schemas.openxmlformats.org/presentationml/2006/main">
+  <p:cSld>
+    <p:bg>
+      <p:bgPr>
+        <a:solidFill>
+          <a:srgbClr val="2B2B30"/>
+        </a:solidFill>
+        <a:effectLst/>
+      </p:bgPr>
+    </p:bg>
+    <p:spTree>
+      <p:nvGrpSpPr>
+        <p:cNvPr id="1" name=""/>
+        <p:cNvGrpSpPr/>
+        <p:nvPr/>
+      </p:nvGrpSpPr>
+      <p:grpSpPr>
+        <a:xfrm>
+          <a:off x="0" y="0"/>
+          <a:ext cx="0" cy="0"/>
+          <a:chOff x="0" y="0"/>
+          <a:chExt cx="0" cy="0"/>
+        </a:xfrm>
+      </p:grpSpPr>
+      <p:sp>
+        <p:nvSpPr>
+          <p:cNvPr id="2" name="Shape 0"/>
+          <p:cNvSpPr/>
+          <p:nvPr/>
+        </p:nvSpPr>
+        <p:spPr>
+          <a:xfrm>
+            <a:off x="8686800" y="1905000"/>
+            <a:ext cx="863600" cy="863600"/>
+          </a:xfrm>
+          <a:prstGeom prst="rect">
+            <a:avLst/>
+          </a:prstGeom>
+          <a:solidFill>
+            <a:srgbClr val="D47BA3"/>
+          </a:solidFill>
+          <a:ln/>
+        </p:spPr>
+        <p:txBody>
+          <a:bodyPr/>
+          <a:lstStyle/>
+          <a:p>
+            <a:pPr marL="0" marR="0" lvl="0" indent="0" algn="l" defTabSz="914400" rtl="0" eaLnBrk="1" fontAlgn="auto" latinLnBrk="0" hangingPunct="1">
+              <a:lnSpc>
+                <a:spcPct val="100000"/>
+              </a:lnSpc>
+              <a:spcBef>
+                <a:spcPts val="0"/>
+              </a:spcBef>
+              <a:spcAft>
+                <a:spcPts val="0"/>
+              </a:spcAft>
+              <a:buClrTx/>
+              <a:buSzTx/>
+              <a:buFontTx/>
+              <a:buNone/>
+              <a:tabLst/>
+              <a:defRPr/>
+            </a:pPr>
+            <a:endParaRPr kumimoji="0" lang="en-CA" sz="1800" b="0" i="0" u="none" strike="noStrike" kern="1200" cap="none" spc="0" normalizeH="0" baseline="0" noProof="0">
+              <a:ln>
+                <a:noFill/>
+              </a:ln>
+              <a:solidFill>
+                <a:srgbClr val="2B2B30"/>
+              </a:solidFill>
+              <a:effectLst/>
+              <a:uLnTx/>
+              <a:uFillTx/>
+              <a:latin typeface="Public Sans"/>
+              <a:ea typeface="+mn-ea"/>
+              <a:cs typeface="+mn-cs"/>
+            </a:endParaRPr>
+          </a:p>
+        </p:txBody>
+      </p:sp>
+      <p:sp>
+        <p:nvSpPr>
+          <p:cNvPr id="3" name="Shape 1"/>
+          <p:cNvSpPr/>
+          <p:nvPr/>
+        </p:nvSpPr>
+        <p:spPr>
+          <a:xfrm>
+            <a:off x="9601200" y="1905000"/>
+            <a:ext cx="863600" cy="863600"/>
+          </a:xfrm>
+          <a:prstGeom prst="rect">
+            <a:avLst/>
+          </a:prstGeom>
+          <a:solidFill>
+            <a:srgbClr val="9E6B92"/>
+          </a:solidFill>
+          <a:ln/>
+        </p:spPr>
+        <p:txBody>
+          <a:bodyPr/>
+          <a:lstStyle/>
+          <a:p>
+            <a:pPr marL="0" marR="0" lvl="0" indent="0" algn="l" defTabSz="914400" rtl="0" eaLnBrk="1" fontAlgn="auto" latinLnBrk="0" hangingPunct="1">
+              <a:lnSpc>
+                <a:spcPct val="100000"/>
+              </a:lnSpc>
+              <a:spcBef>
+                <a:spcPts val="0"/>
+              </a:spcBef>
+              <a:spcAft>
+                <a:spcPts val="0"/>
+              </a:spcAft>
+              <a:buClrTx/>
+              <a:buSzTx/>
+              <a:buFontTx/>
+              <a:buNone/>
+              <a:tabLst/>
+              <a:defRPr/>
+            </a:pPr>
+            <a:endParaRPr kumimoji="0" lang="en-CA" sz="1800" b="0" i="0" u="none" strike="noStrike" kern="1200" cap="none" spc="0" normalizeH="0" baseline="0" noProof="0">
+              <a:ln>
+                <a:noFill/>
+              </a:ln>
+              <a:solidFill>
+                <a:srgbClr val="2B2B30"/>
+              </a:solidFill>
+              <a:effectLst/>
+              <a:uLnTx/>
+              <a:uFillTx/>
+              <a:latin typeface="Public Sans"/>
+              <a:ea typeface="+mn-ea"/>
+              <a:cs typeface="+mn-cs"/>
+            </a:endParaRPr>
+          </a:p>
+        </p:txBody>
+      </p:sp>
+      <p:sp>
+        <p:nvSpPr>
+          <p:cNvPr id="4" name="Shape 2"/>
+          <p:cNvSpPr/>
+          <p:nvPr/>
+        </p:nvSpPr>
+        <p:spPr>
+          <a:xfrm>
+            <a:off x="10515600" y="1905000"/>
+            <a:ext cx="863600" cy="863600"/>
+          </a:xfrm>
+          <a:prstGeom prst="rect">
+            <a:avLst/>
+          </a:prstGeom>
+          <a:solidFill>
+            <a:srgbClr val="4A4A78"/>
+          </a:solidFill>
+          <a:ln/>
+        </p:spPr>
+        <p:txBody>
+          <a:bodyPr/>
+          <a:lstStyle/>
+          <a:p>
+            <a:pPr marL="0" marR="0" lvl="0" indent="0" algn="l" defTabSz="914400" rtl="0" eaLnBrk="1" fontAlgn="auto" latinLnBrk="0" hangingPunct="1">
+              <a:lnSpc>
+                <a:spcPct val="100000"/>
+              </a:lnSpc>
+              <a:spcBef>
+                <a:spcPts val="0"/>
+              </a:spcBef>
+              <a:spcAft>
+                <a:spcPts val="0"/>
+              </a:spcAft>
+              <a:buClrTx/>
+              <a:buSzTx/>
+              <a:buFontTx/>
+              <a:buNone/>
+              <a:tabLst/>
+              <a:defRPr/>
+            </a:pPr>
+            <a:endParaRPr kumimoji="0" lang="en-CA" sz="1800" b="0" i="0" u="none" strike="noStrike" kern="1200" cap="none" spc="0" normalizeH="0" baseline="0" noProof="0">
+              <a:ln>
+                <a:noFill/>
+              </a:ln>
+              <a:solidFill>
+                <a:srgbClr val="2B2B30"/>
+              </a:solidFill>
+              <a:effectLst/>
+              <a:uLnTx/>
+              <a:uFillTx/>
+              <a:latin typeface="Public Sans"/>
+              <a:ea typeface="+mn-ea"/>
+              <a:cs typeface="+mn-cs"/>
+            </a:endParaRPr>
+          </a:p>
+        </p:txBody>
+      </p:sp>
+      <p:sp>
+        <p:nvSpPr>
+          <p:cNvPr id="5" name="Shape 3"/>
+          <p:cNvSpPr/>
+          <p:nvPr/>
+        </p:nvSpPr>
+        <p:spPr>
+          <a:xfrm>
+            <a:off x="8686800" y="2819400"/>
+            <a:ext cx="863600" cy="863600"/>
+          </a:xfrm>
+          <a:prstGeom prst="rect">
+            <a:avLst/>
+          </a:prstGeom>
+          <a:solidFill>
+            <a:srgbClr val="DBB7CF"/>
+          </a:solidFill>
+          <a:ln/>
+        </p:spPr>
+        <p:txBody>
+          <a:bodyPr/>
+          <a:lstStyle/>
+          <a:p>
+            <a:pPr marL="0" marR="0" lvl="0" indent="0" algn="l" defTabSz="914400" rtl="0" eaLnBrk="1" fontAlgn="auto" latinLnBrk="0" hangingPunct="1">
+              <a:lnSpc>
+                <a:spcPct val="100000"/>
+              </a:lnSpc>
+              <a:spcBef>
+                <a:spcPts val="0"/>
+              </a:spcBef>
+              <a:spcAft>
+                <a:spcPts val="0"/>
+              </a:spcAft>
+              <a:buClrTx/>
+              <a:buSzTx/>
+              <a:buFontTx/>
+              <a:buNone/>
+              <a:tabLst/>
+              <a:defRPr/>
+            </a:pPr>
+            <a:endParaRPr kumimoji="0" lang="en-CA" sz="1800" b="0" i="0" u="none" strike="noStrike" kern="1200" cap="none" spc="0" normalizeH="0" baseline="0" noProof="0">
+              <a:ln>
+                <a:noFill/>
+              </a:ln>
+              <a:solidFill>
+                <a:srgbClr val="2B2B30"/>
+              </a:solidFill>
+              <a:effectLst/>
+              <a:uLnTx/>
+              <a:uFillTx/>
+              <a:latin typeface="Public Sans"/>
+              <a:ea typeface="+mn-ea"/>
+              <a:cs typeface="+mn-cs"/>
+            </a:endParaRPr>
+          </a:p>
+        </p:txBody>
+      </p:sp>
+      <p:sp>
+        <p:nvSpPr>
+          <p:cNvPr id="6" name="Shape 4"/>
+          <p:cNvSpPr/>
+          <p:nvPr/>
+        </p:nvSpPr>
+        <p:spPr>
+          <a:xfrm>
+            <a:off x="9601200" y="2819400"/>
+            <a:ext cx="863600" cy="863600"/>
+          </a:xfrm>
+          <a:prstGeom prst="rect">
+            <a:avLst/>
+          </a:prstGeom>
+          <a:solidFill>
+            <a:srgbClr val="A3A3C8"/>
+          </a:solidFill>
+          <a:ln/>
+        </p:spPr>
+        <p:txBody>
+          <a:bodyPr/>
+          <a:lstStyle/>
+          <a:p>
+            <a:pPr marL="0" marR="0" lvl="0" indent="0" algn="l" defTabSz="914400" rtl="0" eaLnBrk="1" fontAlgn="auto" latinLnBrk="0" hangingPunct="1">
+              <a:lnSpc>
+                <a:spcPct val="100000"/>
+              </a:lnSpc>
+              <a:spcBef>
+                <a:spcPts val="0"/>
+              </a:spcBef>
+              <a:spcAft>
+                <a:spcPts val="0"/>
+              </a:spcAft>
+              <a:buClrTx/>
+              <a:buSzTx/>
+              <a:buFontTx/>
+              <a:buNone/>
+              <a:tabLst/>
+              <a:defRPr/>
+            </a:pPr>
+            <a:endParaRPr kumimoji="0" lang="en-CA" sz="1800" b="0" i="0" u="none" strike="noStrike" kern="1200" cap="none" spc="0" normalizeH="0" baseline="0" noProof="0">
+              <a:ln>
+                <a:noFill/>
+              </a:ln>
+              <a:solidFill>
+                <a:srgbClr val="2B2B30"/>
+              </a:solidFill>
+              <a:effectLst/>
+              <a:uLnTx/>
+              <a:uFillTx/>
+              <a:latin typeface="Public Sans"/>
+              <a:ea typeface="+mn-ea"/>
+              <a:cs typeface="+mn-cs"/>
+            </a:endParaRPr>
+          </a:p>
+        </p:txBody>
+      </p:sp>
+      <p:sp>
+        <p:nvSpPr>
+          <p:cNvPr id="7" name="Shape 5"/>
+          <p:cNvSpPr/>
+          <p:nvPr/>
+        </p:nvSpPr>
+        <p:spPr>
+          <a:xfrm>
+            <a:off x="10515600" y="2819400"/>
+            <a:ext cx="863600" cy="863600"/>
+          </a:xfrm>
+          <a:prstGeom prst="rect">
+            <a:avLst/>
+          </a:prstGeom>
+          <a:solidFill>
+            <a:srgbClr val="56709E"/>
+          </a:solidFill>
+          <a:ln/>
+        </p:spPr>
+        <p:txBody>
+          <a:bodyPr/>
+          <a:lstStyle/>
+          <a:p>
+            <a:pPr marL="0" marR="0" lvl="0" indent="0" algn="l" defTabSz="914400" rtl="0" eaLnBrk="1" fontAlgn="auto" latinLnBrk="0" hangingPunct="1">
+              <a:lnSpc>
+                <a:spcPct val="100000"/>
+              </a:lnSpc>
+              <a:spcBef>
+                <a:spcPts val="0"/>
+              </a:spcBef>
+              <a:spcAft>
+                <a:spcPts val="0"/>
+              </a:spcAft>
+              <a:buClrTx/>
+              <a:buSzTx/>
+              <a:buFontTx/>
+              <a:buNone/>
+              <a:tabLst/>
+              <a:defRPr/>
+            </a:pPr>
+            <a:endParaRPr kumimoji="0" lang="en-CA" sz="1800" b="0" i="0" u="none" strike="noStrike" kern="1200" cap="none" spc="0" normalizeH="0" baseline="0" noProof="0">
+              <a:ln>
+                <a:noFill/>
+              </a:ln>
+              <a:solidFill>
+                <a:srgbClr val="2B2B30"/>
+              </a:solidFill>
+              <a:effectLst/>
+              <a:uLnTx/>
+              <a:uFillTx/>
+              <a:latin typeface="Public Sans"/>
+              <a:ea typeface="+mn-ea"/>
+              <a:cs typeface="+mn-cs"/>
+            </a:endParaRPr>
+          </a:p>
+        </p:txBody>
+      </p:sp>
+      <p:sp>
+        <p:nvSpPr>
+          <p:cNvPr id="8" name="Shape 6"/>
+          <p:cNvSpPr/>
+          <p:nvPr/>
+        </p:nvSpPr>
+        <p:spPr>
+          <a:xfrm>
+            <a:off x="8686800" y="3733800"/>
+            <a:ext cx="863600" cy="863600"/>
+          </a:xfrm>
+          <a:prstGeom prst="rect">
+            <a:avLst/>
+          </a:prstGeom>
+          <a:solidFill>
+            <a:srgbClr val="EAE1D2"/>
+          </a:solidFill>
+          <a:ln/>
+        </p:spPr>
+        <p:txBody>
+          <a:bodyPr/>
+          <a:lstStyle/>
+          <a:p>
+            <a:pPr marL="0" marR="0" lvl="0" indent="0" algn="l" defTabSz="914400" rtl="0" eaLnBrk="1" fontAlgn="auto" latinLnBrk="0" hangingPunct="1">
+              <a:lnSpc>
+                <a:spcPct val="100000"/>
+              </a:lnSpc>
+              <a:spcBef>
+                <a:spcPts val="0"/>
+              </a:spcBef>
+              <a:spcAft>
+                <a:spcPts val="0"/>
+              </a:spcAft>
+              <a:buClrTx/>
+              <a:buSzTx/>
+              <a:buFontTx/>
+              <a:buNone/>
+              <a:tabLst/>
+              <a:defRPr/>
+            </a:pPr>
+            <a:endParaRPr kumimoji="0" lang="en-CA" sz="1800" b="0" i="0" u="none" strike="noStrike" kern="1200" cap="none" spc="0" normalizeH="0" baseline="0" noProof="0">
+              <a:ln>
+                <a:noFill/>
+              </a:ln>
+              <a:solidFill>
+                <a:srgbClr val="2B2B30"/>
+              </a:solidFill>
+              <a:effectLst/>
+              <a:uLnTx/>
+              <a:uFillTx/>
+              <a:latin typeface="Public Sans"/>
+              <a:ea typeface="+mn-ea"/>
+              <a:cs typeface="+mn-cs"/>
+            </a:endParaRPr>
+          </a:p>
+        </p:txBody>
+      </p:sp>
+      <p:sp>
+        <p:nvSpPr>
+          <p:cNvPr id="9" name="Shape 7"/>
+          <p:cNvSpPr/>
+          <p:nvPr/>
+        </p:nvSpPr>
+        <p:spPr>
+          <a:xfrm>
+            <a:off x="9601200" y="3733800"/>
+            <a:ext cx="863600" cy="863600"/>
+          </a:xfrm>
+          <a:prstGeom prst="rect">
+            <a:avLst/>
+          </a:prstGeom>
+          <a:solidFill>
+            <a:srgbClr val="B5C0DA"/>
+          </a:solidFill>
+          <a:ln/>
+        </p:spPr>
+        <p:txBody>
+          <a:bodyPr/>
+          <a:lstStyle/>
+          <a:p>
+            <a:pPr marL="0" marR="0" lvl="0" indent="0" algn="l" defTabSz="914400" rtl="0" eaLnBrk="1" fontAlgn="auto" latinLnBrk="0" hangingPunct="1">
+              <a:lnSpc>
+                <a:spcPct val="100000"/>
+              </a:lnSpc>
+              <a:spcBef>
+                <a:spcPts val="0"/>
+              </a:spcBef>
+              <a:spcAft>
+                <a:spcPts val="0"/>
+              </a:spcAft>
+              <a:buClrTx/>
+              <a:buSzTx/>
+              <a:buFontTx/>
+              <a:buNone/>
+              <a:tabLst/>
+              <a:defRPr/>
+            </a:pPr>
+            <a:endParaRPr kumimoji="0" lang="en-CA" sz="1800" b="0" i="0" u="none" strike="noStrike" kern="1200" cap="none" spc="0" normalizeH="0" baseline="0" noProof="0">
+              <a:ln>
+                <a:noFill/>
+              </a:ln>
+              <a:solidFill>
+                <a:srgbClr val="2B2B30"/>
+              </a:solidFill>
+              <a:effectLst/>
+              <a:uLnTx/>
+              <a:uFillTx/>
+              <a:latin typeface="Public Sans"/>
+              <a:ea typeface="+mn-ea"/>
+              <a:cs typeface="+mn-cs"/>
+            </a:endParaRPr>
+          </a:p>
+        </p:txBody>
+      </p:sp>
+      <p:sp>
+        <p:nvSpPr>
+          <p:cNvPr id="10" name="Shape 8"/>
+          <p:cNvSpPr/>
+          <p:nvPr/>
+        </p:nvSpPr>
+        <p:spPr>
+          <a:xfrm>
+            <a:off x="10515600" y="3733800"/>
+            <a:ext cx="863600" cy="863600"/>
+          </a:xfrm>
+          <a:prstGeom prst="rect">
+            <a:avLst/>
+          </a:prstGeom>
+          <a:solidFill>
+            <a:srgbClr val="6C83B5"/>
+          </a:solidFill>
+          <a:ln/>
+        </p:spPr>
+        <p:txBody>
+          <a:bodyPr/>
+          <a:lstStyle/>
+          <a:p>
+            <a:pPr marL="0" marR="0" lvl="0" indent="0" algn="l" defTabSz="914400" rtl="0" eaLnBrk="1" fontAlgn="auto" latinLnBrk="0" hangingPunct="1">
+              <a:lnSpc>
+                <a:spcPct val="100000"/>
+              </a:lnSpc>
+              <a:spcBef>
+                <a:spcPts val="0"/>
+              </a:spcBef>
+              <a:spcAft>
+                <a:spcPts val="0"/>
+              </a:spcAft>
+              <a:buClrTx/>
+              <a:buSzTx/>
+              <a:buFontTx/>
+              <a:buNone/>
+              <a:tabLst/>
+              <a:defRPr/>
+            </a:pPr>
+            <a:endParaRPr kumimoji="0" lang="en-CA" sz="1800" b="0" i="0" u="none" strike="noStrike" kern="1200" cap="none" spc="0" normalizeH="0" baseline="0" noProof="0">
+              <a:ln>
+                <a:noFill/>
+              </a:ln>
+              <a:solidFill>
+                <a:srgbClr val="2B2B30"/>
+              </a:solidFill>
+              <a:effectLst/>
+              <a:uLnTx/>
+              <a:uFillTx/>
+              <a:latin typeface="Public Sans"/>
+              <a:ea typeface="+mn-ea"/>
+              <a:cs typeface="+mn-cs"/>
+            </a:endParaRPr>
+          </a:p>
+        </p:txBody>
+      </p:sp>
+      <p:sp>
+        <p:nvSpPr>
+          <p:cNvPr id="11" name="Text 9"/>
+          <p:cNvSpPr>
+            <a:spLocks noGrp="1"/>
+          </p:cNvSpPr>
+          <p:nvPr>
+            <p:ph type="title"/>
+          </p:nvPr>
+        </p:nvSpPr>
+        <p:spPr>
+          <a:xfrm>
+            <a:off x="812800" y="2771142"/>
+            <a:ext cx="7194550" cy="695960"/>
+          </a:xfrm>
+          <a:prstGeom prst="rect">
+            <a:avLst/>
+          </a:prstGeom>
+          <a:noFill/>
+          <a:ln/>
+        </p:spPr>
+        <p:txBody>
+          <a:bodyPr wrap="square" lIns="0" tIns="0" rIns="0" bIns="0" rtlCol="0" anchor="t">
+            <a:normAutofit/>
+          </a:bodyPr>
+          <a:lstStyle/>
+          <a:p>
+            <a:pPr marL="0" indent="0" algn="l">
+              <a:lnSpc>
+                <a:spcPts val="5280"/>
+              </a:lnSpc>
+              <a:buNone/>
+            </a:pPr>
+            <a:r>
+              <a:rPr lang="en-US" sz="4800" b="1" i="0" dirty="0">
+                <a:solidFill>
+                  <a:srgbClr val="F4EEE3"/>
+                </a:solidFill>
+                <a:latin typeface="Libre Baskerville" pitchFamily="18" charset="0"/>
+                <a:ea typeface="Libre Baskerville" pitchFamily="18" charset="-122"/>
+                <a:cs typeface="Libre Baskerville" pitchFamily="18" charset="-120"/>
+              </a:rPr>
+              <a:t>Thank you</a:t>
+            </a:r>
+            <a:endParaRPr lang="en-US" sz="4800" dirty="0"/>
+          </a:p>
+        </p:txBody>
+      </p:sp>
+      <p:sp>
+        <p:nvSpPr>
+          <p:cNvPr id="12" name="Text 10"/>
+          <p:cNvSpPr/>
+          <p:nvPr/>
+        </p:nvSpPr>
+        <p:spPr>
+          <a:xfrm>
+            <a:off x="812800" y="3695700"/>
+            <a:ext cx="7194550" cy="416560"/>
+          </a:xfrm>
+          <a:prstGeom prst="rect">
+            <a:avLst/>
+          </a:prstGeom>
+          <a:noFill/>
+          <a:ln/>
+        </p:spPr>
+        <p:txBody>
+          <a:bodyPr wrap="square" lIns="0" tIns="0" rIns="0" bIns="0" rtlCol="0" anchor="t">
+            <a:normAutofit/>
+          </a:bodyPr>
+          <a:lstStyle/>
+          <a:p>
+            <a:pPr marL="0" marR="0" lvl="0" indent="0" algn="l" defTabSz="914400" rtl="0" eaLnBrk="1" fontAlgn="auto" latinLnBrk="0" hangingPunct="1">
+              <a:lnSpc>
+                <a:spcPts val="3080"/>
+              </a:lnSpc>
+              <a:spcBef>
+                <a:spcPts val="0"/>
+              </a:spcBef>
+              <a:spcAft>
+                <a:spcPts val="0"/>
+              </a:spcAft>
+              <a:buClrTx/>
+              <a:buSzTx/>
+              <a:buFontTx/>
+              <a:buNone/>
+              <a:tabLst/>
+              <a:defRPr/>
+            </a:pPr>
+            <a:r>
+              <a:rPr kumimoji="0" lang="en-US" sz="2200" b="0" i="0" u="none" strike="noStrike" kern="1200" cap="none" spc="0" normalizeH="0" baseline="0" noProof="0" dirty="0">
+                <a:ln>
+                  <a:noFill/>
+                </a:ln>
+                <a:solidFill>
+                  <a:srgbClr val="E39BBE"/>
+                </a:solidFill>
+                <a:effectLst/>
+                <a:uLnTx/>
+                <a:uFillTx/>
+                <a:latin typeface="Public Sans" pitchFamily="34" charset="0"/>
+                <a:ea typeface="Public Sans" pitchFamily="34" charset="-122"/>
+                <a:cs typeface="Public Sans" pitchFamily="34" charset="-120"/>
+              </a:rPr>
+              <a:t>Questions?</a:t>
+            </a:r>
+            <a:endParaRPr kumimoji="0" lang="en-US" sz="2200" b="0" i="0" u="none" strike="noStrike" kern="1200" cap="none" spc="0" normalizeH="0" baseline="0" noProof="0" dirty="0">
+              <a:ln>
+                <a:noFill/>
+              </a:ln>
+              <a:solidFill>
+                <a:srgbClr val="2B2B30"/>
+              </a:solidFill>
+              <a:effectLst/>
+              <a:uLnTx/>
+              <a:uFillTx/>
+              <a:ea typeface="+mn-ea"/>
+              <a:cs typeface="+mn-cs"/>
+            </a:endParaRPr>
+          </a:p>
+        </p:txBody>
+      </p:sp>
+      <p:sp>
+        <p:nvSpPr>
+          <p:cNvPr id="13" name="Text 11"/>
+          <p:cNvSpPr/>
+          <p:nvPr/>
+        </p:nvSpPr>
+        <p:spPr>
+          <a:xfrm>
+            <a:off x="812800" y="5999479"/>
+            <a:ext cx="7194550" cy="274320"/>
+          </a:xfrm>
+          <a:prstGeom prst="rect">
+            <a:avLst/>
+          </a:prstGeom>
+          <a:noFill/>
+          <a:ln/>
+        </p:spPr>
+        <p:txBody>
+          <a:bodyPr wrap="square" lIns="0" tIns="0" rIns="0" bIns="0" rtlCol="0" anchor="t">
+            <a:normAutofit/>
+          </a:bodyPr>
+          <a:lstStyle/>
+          <a:p>
+            <a:pPr marL="0" marR="0" lvl="0" indent="0" algn="l" defTabSz="914400" rtl="0" eaLnBrk="1" fontAlgn="auto" latinLnBrk="0" hangingPunct="1">
+              <a:lnSpc>
+                <a:spcPts val="1960"/>
+              </a:lnSpc>
+              <a:spcBef>
+                <a:spcPts val="0"/>
+              </a:spcBef>
+              <a:spcAft>
+                <a:spcPts val="0"/>
+              </a:spcAft>
+              <a:buClrTx/>
+              <a:buSzTx/>
+              <a:buFontTx/>
+              <a:buNone/>
+              <a:tabLst/>
+              <a:defRPr/>
+            </a:pPr>
+            <a:endParaRPr kumimoji="0" lang="en-US" sz="1400" b="0" i="0" u="none" strike="noStrike" kern="1200" cap="none" spc="0" normalizeH="0" baseline="0" noProof="0" dirty="0">
+              <a:ln>
+                <a:noFill/>
+              </a:ln>
+              <a:solidFill>
+                <a:srgbClr val="2B2B30"/>
+              </a:solidFill>
+              <a:effectLst/>
+              <a:uLnTx/>
+              <a:uFillTx/>
+              <a:latin typeface="Public Sans"/>
+              <a:ea typeface="+mn-ea"/>
+              <a:cs typeface="+mn-cs"/>
+            </a:endParaRPr>
           </a:p>
         </p:txBody>
       </p:sp>
@@ -6444,6 +7396,1374 @@
 <file path=ppt/slides/slide6.xml><?xml version="1.0" encoding="utf-8"?>
 <p:sld xmlns:a="http://schemas.openxmlformats.org/drawingml/2006/main" xmlns:r="http://schemas.openxmlformats.org/officeDocument/2006/relationships" xmlns:p="http://schemas.openxmlformats.org/presentationml/2006/main">
   <p:cSld>
+    <p:spTree>
+      <p:nvGrpSpPr>
+        <p:cNvPr id="1" name=""/>
+        <p:cNvGrpSpPr/>
+        <p:nvPr/>
+      </p:nvGrpSpPr>
+      <p:grpSpPr>
+        <a:xfrm>
+          <a:off x="0" y="0"/>
+          <a:ext cx="0" cy="0"/>
+          <a:chOff x="0" y="0"/>
+          <a:chExt cx="0" cy="0"/>
+        </a:xfrm>
+      </p:grpSpPr>
+      <p:sp>
+        <p:nvSpPr>
+          <p:cNvPr id="2" name="Text 0"/>
+          <p:cNvSpPr>
+            <a:spLocks noGrp="1"/>
+          </p:cNvSpPr>
+          <p:nvPr>
+            <p:ph type="title"/>
+          </p:nvPr>
+        </p:nvSpPr>
+        <p:spPr>
+          <a:xfrm>
+            <a:off x="812800" y="812800"/>
+            <a:ext cx="10883392" cy="492720"/>
+          </a:xfrm>
+          <a:prstGeom prst="rect">
+            <a:avLst/>
+          </a:prstGeom>
+          <a:noFill/>
+          <a:ln/>
+        </p:spPr>
+        <p:txBody>
+          <a:bodyPr wrap="square" lIns="0" tIns="0" rIns="0" bIns="0" rtlCol="0" anchor="t">
+            <a:normAutofit/>
+          </a:bodyPr>
+          <a:lstStyle/>
+          <a:p>
+            <a:pPr marL="0" indent="0" algn="l">
+              <a:lnSpc>
+                <a:spcPts val="3680"/>
+              </a:lnSpc>
+              <a:buNone/>
+            </a:pPr>
+            <a:r>
+              <a:rPr lang="en-US" sz="3200" b="1" i="0" dirty="0">
+                <a:solidFill>
+                  <a:srgbClr val="2B2B30"/>
+                </a:solidFill>
+                <a:latin typeface="Libre Baskerville" pitchFamily="18" charset="0"/>
+                <a:ea typeface="Libre Baskerville" pitchFamily="18" charset="-122"/>
+                <a:cs typeface="Libre Baskerville" pitchFamily="18" charset="-120"/>
+              </a:rPr>
+              <a:t>Data wrangling and cleaning</a:t>
+            </a:r>
+            <a:endParaRPr lang="en-US" sz="3200" dirty="0"/>
+          </a:p>
+        </p:txBody>
+      </p:sp>
+      <p:sp>
+        <p:nvSpPr>
+          <p:cNvPr id="3" name="Shape 1"/>
+          <p:cNvSpPr/>
+          <p:nvPr/>
+        </p:nvSpPr>
+        <p:spPr>
+          <a:xfrm>
+            <a:off x="812800" y="1534120"/>
+            <a:ext cx="3386634" cy="1878211"/>
+          </a:xfrm>
+          <a:prstGeom prst="roundRect">
+            <a:avLst>
+              <a:gd name="adj" fmla="val 4057"/>
+            </a:avLst>
+          </a:prstGeom>
+          <a:solidFill>
+            <a:srgbClr val="FFFFFF"/>
+          </a:solidFill>
+          <a:ln/>
+        </p:spPr>
+        <p:txBody>
+          <a:bodyPr/>
+          <a:lstStyle/>
+          <a:p>
+            <a:endParaRPr lang="en-US"/>
+          </a:p>
+        </p:txBody>
+      </p:sp>
+      <p:sp>
+        <p:nvSpPr>
+          <p:cNvPr id="4" name="Shape 2"/>
+          <p:cNvSpPr/>
+          <p:nvPr/>
+        </p:nvSpPr>
+        <p:spPr>
+          <a:xfrm>
+            <a:off x="812800" y="1534120"/>
+            <a:ext cx="3386634" cy="1878211"/>
+          </a:xfrm>
+          <a:custGeom>
+            <a:avLst/>
+            <a:gdLst/>
+            <a:ahLst/>
+            <a:cxnLst/>
+            <a:rect l="l" t="t" r="r" b="b"/>
+            <a:pathLst>
+              <a:path w="3386634" h="1878211">
+                <a:moveTo>
+                  <a:pt x="0" y="76200"/>
+                </a:moveTo>
+                <a:lnTo>
+                  <a:pt x="0" y="76200"/>
+                </a:lnTo>
+                <a:arcTo wR="76200" hR="76200" stAng="10800000" swAng="5400000"/>
+                <a:lnTo>
+                  <a:pt x="3310434" y="0"/>
+                </a:lnTo>
+                <a:arcTo wR="76200" hR="76200" stAng="16200000" swAng="5400000"/>
+                <a:lnTo>
+                  <a:pt x="3386634" y="76200"/>
+                </a:lnTo>
+                <a:arcTo wR="76200" hR="38100" stAng="0" swAng="-5400000"/>
+                <a:lnTo>
+                  <a:pt x="76200" y="38100"/>
+                </a:lnTo>
+                <a:arcTo wR="76200" hR="38100" stAng="16200000" swAng="-5400000"/>
+                <a:close/>
+              </a:path>
+            </a:pathLst>
+          </a:custGeom>
+          <a:solidFill>
+            <a:srgbClr val="B4467E"/>
+          </a:solidFill>
+          <a:ln/>
+        </p:spPr>
+        <p:txBody>
+          <a:bodyPr/>
+          <a:lstStyle/>
+          <a:p>
+            <a:endParaRPr lang="en-US"/>
+          </a:p>
+        </p:txBody>
+      </p:sp>
+      <p:sp>
+        <p:nvSpPr>
+          <p:cNvPr id="5" name="Text 3"/>
+          <p:cNvSpPr/>
+          <p:nvPr/>
+        </p:nvSpPr>
+        <p:spPr>
+          <a:xfrm>
+            <a:off x="1041400" y="1750020"/>
+            <a:ext cx="3017317" cy="238720"/>
+          </a:xfrm>
+          <a:prstGeom prst="rect">
+            <a:avLst/>
+          </a:prstGeom>
+          <a:noFill/>
+          <a:ln/>
+        </p:spPr>
+        <p:txBody>
+          <a:bodyPr wrap="square" lIns="0" tIns="0" rIns="0" bIns="0" rtlCol="0" anchor="t">
+            <a:normAutofit/>
+          </a:bodyPr>
+          <a:lstStyle/>
+          <a:p>
+            <a:pPr marL="0" indent="0" algn="l">
+              <a:lnSpc>
+                <a:spcPts val="1680"/>
+              </a:lnSpc>
+              <a:buNone/>
+            </a:pPr>
+            <a:r>
+              <a:rPr lang="en-US" sz="1400" b="1" dirty="0">
+                <a:solidFill>
+                  <a:srgbClr val="2B2B30"/>
+                </a:solidFill>
+                <a:latin typeface="Public Sans" pitchFamily="34" charset="0"/>
+                <a:ea typeface="Public Sans" pitchFamily="34" charset="-122"/>
+                <a:cs typeface="Public Sans" pitchFamily="34" charset="-120"/>
+              </a:rPr>
+              <a:t>1 · Kept full years</a:t>
+            </a:r>
+            <a:endParaRPr lang="en-US" sz="1400" dirty="0"/>
+          </a:p>
+        </p:txBody>
+      </p:sp>
+      <p:sp>
+        <p:nvSpPr>
+          <p:cNvPr id="6" name="Text 4"/>
+          <p:cNvSpPr/>
+          <p:nvPr/>
+        </p:nvSpPr>
+        <p:spPr>
+          <a:xfrm>
+            <a:off x="1041400" y="2026841"/>
+            <a:ext cx="3017317" cy="346670"/>
+          </a:xfrm>
+          <a:prstGeom prst="rect">
+            <a:avLst/>
+          </a:prstGeom>
+          <a:noFill/>
+          <a:ln/>
+        </p:spPr>
+        <p:txBody>
+          <a:bodyPr wrap="square" lIns="0" tIns="0" rIns="0" bIns="0" rtlCol="0" anchor="t">
+            <a:normAutofit/>
+          </a:bodyPr>
+          <a:lstStyle/>
+          <a:p>
+            <a:pPr marL="0" indent="0" algn="l">
+              <a:lnSpc>
+                <a:spcPts val="2530"/>
+              </a:lnSpc>
+              <a:buNone/>
+            </a:pPr>
+            <a:r>
+              <a:rPr lang="en-US" sz="2200" b="1" dirty="0">
+                <a:solidFill>
+                  <a:srgbClr val="B4467E"/>
+                </a:solidFill>
+                <a:latin typeface="Libre Baskerville" pitchFamily="18" charset="0"/>
+                <a:ea typeface="Libre Baskerville" pitchFamily="18" charset="-122"/>
+                <a:cs typeface="Libre Baskerville" pitchFamily="18" charset="-120"/>
+              </a:rPr>
+              <a:t>65,138 → 58,536</a:t>
+            </a:r>
+            <a:endParaRPr lang="en-US" sz="2200" dirty="0"/>
+          </a:p>
+        </p:txBody>
+      </p:sp>
+      <p:sp>
+        <p:nvSpPr>
+          <p:cNvPr id="7" name="Text 5"/>
+          <p:cNvSpPr/>
+          <p:nvPr/>
+        </p:nvSpPr>
+        <p:spPr>
+          <a:xfrm>
+            <a:off x="1041400" y="2411611"/>
+            <a:ext cx="3017317" cy="436860"/>
+          </a:xfrm>
+          <a:prstGeom prst="rect">
+            <a:avLst/>
+          </a:prstGeom>
+          <a:noFill/>
+          <a:ln/>
+        </p:spPr>
+        <p:txBody>
+          <a:bodyPr wrap="square" lIns="0" tIns="0" rIns="0" bIns="0" rtlCol="0" anchor="t">
+            <a:normAutofit/>
+          </a:bodyPr>
+          <a:lstStyle/>
+          <a:p>
+            <a:pPr marL="0" indent="0" algn="l">
+              <a:lnSpc>
+                <a:spcPts val="1620"/>
+              </a:lnSpc>
+              <a:buNone/>
+            </a:pPr>
+            <a:r>
+              <a:rPr lang="en-US" sz="1200" dirty="0">
+                <a:solidFill>
+                  <a:srgbClr val="4A4A52"/>
+                </a:solidFill>
+                <a:latin typeface="Public Sans" pitchFamily="34" charset="0"/>
+                <a:ea typeface="Public Sans" pitchFamily="34" charset="-122"/>
+                <a:cs typeface="Public Sans" pitchFamily="34" charset="-120"/>
+              </a:rPr>
+              <a:t>Dropped the partial years at each end (Dec 2016 and 2026), leaving 2017–2025.</a:t>
+            </a:r>
+            <a:endParaRPr lang="en-US" sz="1200" dirty="0"/>
+          </a:p>
+        </p:txBody>
+      </p:sp>
+      <p:sp>
+        <p:nvSpPr>
+          <p:cNvPr id="8" name="Shape 6"/>
+          <p:cNvSpPr/>
+          <p:nvPr/>
+        </p:nvSpPr>
+        <p:spPr>
+          <a:xfrm>
+            <a:off x="4402634" y="1534120"/>
+            <a:ext cx="3386683" cy="1878211"/>
+          </a:xfrm>
+          <a:prstGeom prst="roundRect">
+            <a:avLst>
+              <a:gd name="adj" fmla="val 4057"/>
+            </a:avLst>
+          </a:prstGeom>
+          <a:solidFill>
+            <a:srgbClr val="FFFFFF"/>
+          </a:solidFill>
+          <a:ln/>
+        </p:spPr>
+        <p:txBody>
+          <a:bodyPr/>
+          <a:lstStyle/>
+          <a:p>
+            <a:endParaRPr lang="en-US"/>
+          </a:p>
+        </p:txBody>
+      </p:sp>
+      <p:sp>
+        <p:nvSpPr>
+          <p:cNvPr id="9" name="Shape 7"/>
+          <p:cNvSpPr/>
+          <p:nvPr/>
+        </p:nvSpPr>
+        <p:spPr>
+          <a:xfrm>
+            <a:off x="4402634" y="1534120"/>
+            <a:ext cx="3386683" cy="1878211"/>
+          </a:xfrm>
+          <a:custGeom>
+            <a:avLst/>
+            <a:gdLst/>
+            <a:ahLst/>
+            <a:cxnLst/>
+            <a:rect l="l" t="t" r="r" b="b"/>
+            <a:pathLst>
+              <a:path w="3386683" h="1878211">
+                <a:moveTo>
+                  <a:pt x="0" y="76200"/>
+                </a:moveTo>
+                <a:lnTo>
+                  <a:pt x="0" y="76200"/>
+                </a:lnTo>
+                <a:arcTo wR="76200" hR="76200" stAng="10800000" swAng="5400000"/>
+                <a:lnTo>
+                  <a:pt x="3310483" y="0"/>
+                </a:lnTo>
+                <a:arcTo wR="76200" hR="76200" stAng="16200000" swAng="5400000"/>
+                <a:lnTo>
+                  <a:pt x="3386683" y="76200"/>
+                </a:lnTo>
+                <a:arcTo wR="76200" hR="38100" stAng="0" swAng="-5400000"/>
+                <a:lnTo>
+                  <a:pt x="76200" y="38100"/>
+                </a:lnTo>
+                <a:arcTo wR="76200" hR="38100" stAng="16200000" swAng="-5400000"/>
+                <a:close/>
+              </a:path>
+            </a:pathLst>
+          </a:custGeom>
+          <a:solidFill>
+            <a:srgbClr val="B4467E"/>
+          </a:solidFill>
+          <a:ln/>
+        </p:spPr>
+        <p:txBody>
+          <a:bodyPr/>
+          <a:lstStyle/>
+          <a:p>
+            <a:endParaRPr lang="en-US"/>
+          </a:p>
+        </p:txBody>
+      </p:sp>
+      <p:sp>
+        <p:nvSpPr>
+          <p:cNvPr id="10" name="Text 8"/>
+          <p:cNvSpPr/>
+          <p:nvPr/>
+        </p:nvSpPr>
+        <p:spPr>
+          <a:xfrm>
+            <a:off x="4631234" y="1750020"/>
+            <a:ext cx="3017368" cy="238720"/>
+          </a:xfrm>
+          <a:prstGeom prst="rect">
+            <a:avLst/>
+          </a:prstGeom>
+          <a:noFill/>
+          <a:ln/>
+        </p:spPr>
+        <p:txBody>
+          <a:bodyPr wrap="square" lIns="0" tIns="0" rIns="0" bIns="0" rtlCol="0" anchor="t">
+            <a:normAutofit/>
+          </a:bodyPr>
+          <a:lstStyle/>
+          <a:p>
+            <a:pPr marL="0" indent="0" algn="l">
+              <a:lnSpc>
+                <a:spcPts val="1680"/>
+              </a:lnSpc>
+              <a:buNone/>
+            </a:pPr>
+            <a:r>
+              <a:rPr lang="en-US" sz="1400" b="1" dirty="0">
+                <a:solidFill>
+                  <a:srgbClr val="2B2B30"/>
+                </a:solidFill>
+                <a:latin typeface="Public Sans" pitchFamily="34" charset="0"/>
+                <a:ea typeface="Public Sans" pitchFamily="34" charset="-122"/>
+                <a:cs typeface="Public Sans" pitchFamily="34" charset="-120"/>
+              </a:rPr>
+              <a:t>2 · Located each incident</a:t>
+            </a:r>
+            <a:endParaRPr lang="en-US" sz="1400" dirty="0"/>
+          </a:p>
+        </p:txBody>
+      </p:sp>
+      <p:sp>
+        <p:nvSpPr>
+          <p:cNvPr id="11" name="Text 9"/>
+          <p:cNvSpPr/>
+          <p:nvPr/>
+        </p:nvSpPr>
+        <p:spPr>
+          <a:xfrm>
+            <a:off x="4631234" y="2026841"/>
+            <a:ext cx="3017368" cy="346670"/>
+          </a:xfrm>
+          <a:prstGeom prst="rect">
+            <a:avLst/>
+          </a:prstGeom>
+          <a:noFill/>
+          <a:ln/>
+        </p:spPr>
+        <p:txBody>
+          <a:bodyPr wrap="square" lIns="0" tIns="0" rIns="0" bIns="0" rtlCol="0" anchor="t">
+            <a:normAutofit/>
+          </a:bodyPr>
+          <a:lstStyle/>
+          <a:p>
+            <a:pPr marL="0" indent="0" algn="l">
+              <a:lnSpc>
+                <a:spcPts val="2530"/>
+              </a:lnSpc>
+              <a:buNone/>
+            </a:pPr>
+            <a:r>
+              <a:rPr lang="en-US" sz="2200" b="1" dirty="0">
+                <a:solidFill>
+                  <a:srgbClr val="B4467E"/>
+                </a:solidFill>
+                <a:latin typeface="Libre Baskerville" pitchFamily="18" charset="0"/>
+                <a:ea typeface="Libre Baskerville" pitchFamily="18" charset="-122"/>
+                <a:cs typeface="Libre Baskerville" pitchFamily="18" charset="-120"/>
+              </a:rPr>
+              <a:t>Point → area</a:t>
+            </a:r>
+            <a:endParaRPr lang="en-US" sz="2200" dirty="0"/>
+          </a:p>
+        </p:txBody>
+      </p:sp>
+      <p:sp>
+        <p:nvSpPr>
+          <p:cNvPr id="12" name="Text 10"/>
+          <p:cNvSpPr/>
+          <p:nvPr/>
+        </p:nvSpPr>
+        <p:spPr>
+          <a:xfrm>
+            <a:off x="4631234" y="2411611"/>
+            <a:ext cx="3017368" cy="848320"/>
+          </a:xfrm>
+          <a:prstGeom prst="rect">
+            <a:avLst/>
+          </a:prstGeom>
+          <a:noFill/>
+          <a:ln/>
+        </p:spPr>
+        <p:txBody>
+          <a:bodyPr wrap="square" lIns="0" tIns="0" rIns="0" bIns="0" rtlCol="0" anchor="t">
+            <a:normAutofit/>
+          </a:bodyPr>
+          <a:lstStyle/>
+          <a:p>
+            <a:pPr marL="0" indent="0" algn="l">
+              <a:lnSpc>
+                <a:spcPts val="1620"/>
+              </a:lnSpc>
+              <a:buNone/>
+            </a:pPr>
+            <a:r>
+              <a:rPr lang="en-US" sz="1200" dirty="0">
+                <a:solidFill>
+                  <a:srgbClr val="4A4A52"/>
+                </a:solidFill>
+                <a:latin typeface="Public Sans" pitchFamily="34" charset="0"/>
+                <a:ea typeface="Public Sans" pitchFamily="34" charset="-122"/>
+                <a:cs typeface="Public Sans" pitchFamily="34" charset="-120"/>
+              </a:rPr>
+              <a:t>GeoPandas in Python checked which area outline each point falls inside. 639 fall outside. The outlines also became the Shape Map.</a:t>
+            </a:r>
+            <a:endParaRPr lang="en-US" sz="1200" dirty="0"/>
+          </a:p>
+        </p:txBody>
+      </p:sp>
+      <p:sp>
+        <p:nvSpPr>
+          <p:cNvPr id="13" name="Shape 11"/>
+          <p:cNvSpPr/>
+          <p:nvPr/>
+        </p:nvSpPr>
+        <p:spPr>
+          <a:xfrm>
+            <a:off x="7992517" y="1534120"/>
+            <a:ext cx="3386634" cy="1878211"/>
+          </a:xfrm>
+          <a:prstGeom prst="roundRect">
+            <a:avLst>
+              <a:gd name="adj" fmla="val 4057"/>
+            </a:avLst>
+          </a:prstGeom>
+          <a:solidFill>
+            <a:srgbClr val="FFFFFF"/>
+          </a:solidFill>
+          <a:ln/>
+        </p:spPr>
+        <p:txBody>
+          <a:bodyPr/>
+          <a:lstStyle/>
+          <a:p>
+            <a:endParaRPr lang="en-US"/>
+          </a:p>
+        </p:txBody>
+      </p:sp>
+      <p:sp>
+        <p:nvSpPr>
+          <p:cNvPr id="14" name="Shape 12"/>
+          <p:cNvSpPr/>
+          <p:nvPr/>
+        </p:nvSpPr>
+        <p:spPr>
+          <a:xfrm>
+            <a:off x="7992517" y="1534120"/>
+            <a:ext cx="3386634" cy="1878211"/>
+          </a:xfrm>
+          <a:custGeom>
+            <a:avLst/>
+            <a:gdLst/>
+            <a:ahLst/>
+            <a:cxnLst/>
+            <a:rect l="l" t="t" r="r" b="b"/>
+            <a:pathLst>
+              <a:path w="3386634" h="1878211">
+                <a:moveTo>
+                  <a:pt x="0" y="76200"/>
+                </a:moveTo>
+                <a:lnTo>
+                  <a:pt x="0" y="76200"/>
+                </a:lnTo>
+                <a:arcTo wR="76200" hR="76200" stAng="10800000" swAng="5400000"/>
+                <a:lnTo>
+                  <a:pt x="3310434" y="0"/>
+                </a:lnTo>
+                <a:arcTo wR="76200" hR="76200" stAng="16200000" swAng="5400000"/>
+                <a:lnTo>
+                  <a:pt x="3386634" y="76200"/>
+                </a:lnTo>
+                <a:arcTo wR="76200" hR="38100" stAng="0" swAng="-5400000"/>
+                <a:lnTo>
+                  <a:pt x="76200" y="38100"/>
+                </a:lnTo>
+                <a:arcTo wR="76200" hR="38100" stAng="16200000" swAng="-5400000"/>
+                <a:close/>
+              </a:path>
+            </a:pathLst>
+          </a:custGeom>
+          <a:solidFill>
+            <a:srgbClr val="B4467E"/>
+          </a:solidFill>
+          <a:ln/>
+        </p:spPr>
+        <p:txBody>
+          <a:bodyPr/>
+          <a:lstStyle/>
+          <a:p>
+            <a:endParaRPr lang="en-US"/>
+          </a:p>
+        </p:txBody>
+      </p:sp>
+      <p:sp>
+        <p:nvSpPr>
+          <p:cNvPr id="15" name="Text 13"/>
+          <p:cNvSpPr/>
+          <p:nvPr/>
+        </p:nvSpPr>
+        <p:spPr>
+          <a:xfrm>
+            <a:off x="8221117" y="1750020"/>
+            <a:ext cx="3017317" cy="238720"/>
+          </a:xfrm>
+          <a:prstGeom prst="rect">
+            <a:avLst/>
+          </a:prstGeom>
+          <a:noFill/>
+          <a:ln/>
+        </p:spPr>
+        <p:txBody>
+          <a:bodyPr wrap="square" lIns="0" tIns="0" rIns="0" bIns="0" rtlCol="0" anchor="t">
+            <a:normAutofit/>
+          </a:bodyPr>
+          <a:lstStyle/>
+          <a:p>
+            <a:pPr marL="0" indent="0" algn="l">
+              <a:lnSpc>
+                <a:spcPts val="1680"/>
+              </a:lnSpc>
+              <a:buNone/>
+            </a:pPr>
+            <a:r>
+              <a:rPr lang="en-US" sz="1400" b="1" dirty="0">
+                <a:solidFill>
+                  <a:srgbClr val="2B2B30"/>
+                </a:solidFill>
+                <a:latin typeface="Public Sans" pitchFamily="34" charset="0"/>
+                <a:ea typeface="Public Sans" pitchFamily="34" charset="-122"/>
+                <a:cs typeface="Public Sans" pitchFamily="34" charset="-120"/>
+              </a:rPr>
+              <a:t>3 · Sorted incidents</a:t>
+            </a:r>
+            <a:endParaRPr lang="en-US" sz="1400" dirty="0"/>
+          </a:p>
+        </p:txBody>
+      </p:sp>
+      <p:sp>
+        <p:nvSpPr>
+          <p:cNvPr id="16" name="Text 14"/>
+          <p:cNvSpPr/>
+          <p:nvPr/>
+        </p:nvSpPr>
+        <p:spPr>
+          <a:xfrm>
+            <a:off x="8221117" y="2026841"/>
+            <a:ext cx="3017317" cy="346670"/>
+          </a:xfrm>
+          <a:prstGeom prst="rect">
+            <a:avLst/>
+          </a:prstGeom>
+          <a:noFill/>
+          <a:ln/>
+        </p:spPr>
+        <p:txBody>
+          <a:bodyPr wrap="square" lIns="0" tIns="0" rIns="0" bIns="0" rtlCol="0" anchor="t">
+            <a:normAutofit/>
+          </a:bodyPr>
+          <a:lstStyle/>
+          <a:p>
+            <a:pPr marL="0" indent="0" algn="l">
+              <a:lnSpc>
+                <a:spcPts val="2530"/>
+              </a:lnSpc>
+              <a:buNone/>
+            </a:pPr>
+            <a:r>
+              <a:rPr lang="en-US" sz="2200" b="1" dirty="0">
+                <a:solidFill>
+                  <a:srgbClr val="B4467E"/>
+                </a:solidFill>
+                <a:latin typeface="Libre Baskerville" pitchFamily="18" charset="0"/>
+                <a:ea typeface="Libre Baskerville" pitchFamily="18" charset="-122"/>
+                <a:cs typeface="Libre Baskerville" pitchFamily="18" charset="-120"/>
+              </a:rPr>
+              <a:t>Text → 5 types</a:t>
+            </a:r>
+            <a:endParaRPr lang="en-US" sz="2200" dirty="0"/>
+          </a:p>
+        </p:txBody>
+      </p:sp>
+      <p:sp>
+        <p:nvSpPr>
+          <p:cNvPr id="17" name="Text 15"/>
+          <p:cNvSpPr/>
+          <p:nvPr/>
+        </p:nvSpPr>
+        <p:spPr>
+          <a:xfrm>
+            <a:off x="8221117" y="2411611"/>
+            <a:ext cx="3017317" cy="848320"/>
+          </a:xfrm>
+          <a:prstGeom prst="rect">
+            <a:avLst/>
+          </a:prstGeom>
+          <a:noFill/>
+          <a:ln/>
+        </p:spPr>
+        <p:txBody>
+          <a:bodyPr wrap="square" lIns="0" tIns="0" rIns="0" bIns="0" rtlCol="0" anchor="t">
+            <a:normAutofit/>
+          </a:bodyPr>
+          <a:lstStyle/>
+          <a:p>
+            <a:pPr marL="0" indent="0" algn="l">
+              <a:lnSpc>
+                <a:spcPts val="1620"/>
+              </a:lnSpc>
+              <a:buNone/>
+            </a:pPr>
+            <a:r>
+              <a:rPr lang="en-US" sz="1200" dirty="0">
+                <a:solidFill>
+                  <a:srgbClr val="4A4A52"/>
+                </a:solidFill>
+                <a:latin typeface="Public Sans" pitchFamily="34" charset="0"/>
+                <a:ea typeface="Public Sans" pitchFamily="34" charset="-122"/>
+                <a:cs typeface="Public Sans" pitchFamily="34" charset="-120"/>
+              </a:rPr>
+              <a:t>Keywords in each description set the incident type. Street names flag highways, so area rates only count local roads.</a:t>
+            </a:r>
+            <a:endParaRPr lang="en-US" sz="1200" dirty="0"/>
+          </a:p>
+        </p:txBody>
+      </p:sp>
+      <p:sp>
+        <p:nvSpPr>
+          <p:cNvPr id="18" name="Shape 16"/>
+          <p:cNvSpPr/>
+          <p:nvPr/>
+        </p:nvSpPr>
+        <p:spPr>
+          <a:xfrm>
+            <a:off x="812800" y="3615531"/>
+            <a:ext cx="3386634" cy="1878211"/>
+          </a:xfrm>
+          <a:prstGeom prst="roundRect">
+            <a:avLst>
+              <a:gd name="adj" fmla="val 4057"/>
+            </a:avLst>
+          </a:prstGeom>
+          <a:solidFill>
+            <a:srgbClr val="FFFFFF"/>
+          </a:solidFill>
+          <a:ln/>
+        </p:spPr>
+        <p:txBody>
+          <a:bodyPr/>
+          <a:lstStyle/>
+          <a:p>
+            <a:endParaRPr lang="en-US"/>
+          </a:p>
+        </p:txBody>
+      </p:sp>
+      <p:sp>
+        <p:nvSpPr>
+          <p:cNvPr id="19" name="Shape 17"/>
+          <p:cNvSpPr/>
+          <p:nvPr/>
+        </p:nvSpPr>
+        <p:spPr>
+          <a:xfrm>
+            <a:off x="812800" y="3615531"/>
+            <a:ext cx="3386634" cy="1878211"/>
+          </a:xfrm>
+          <a:custGeom>
+            <a:avLst/>
+            <a:gdLst/>
+            <a:ahLst/>
+            <a:cxnLst/>
+            <a:rect l="l" t="t" r="r" b="b"/>
+            <a:pathLst>
+              <a:path w="3386634" h="1878211">
+                <a:moveTo>
+                  <a:pt x="0" y="76200"/>
+                </a:moveTo>
+                <a:lnTo>
+                  <a:pt x="0" y="76200"/>
+                </a:lnTo>
+                <a:arcTo wR="76200" hR="76200" stAng="10800000" swAng="5400000"/>
+                <a:lnTo>
+                  <a:pt x="3310434" y="0"/>
+                </a:lnTo>
+                <a:arcTo wR="76200" hR="76200" stAng="16200000" swAng="5400000"/>
+                <a:lnTo>
+                  <a:pt x="3386634" y="76200"/>
+                </a:lnTo>
+                <a:arcTo wR="76200" hR="38100" stAng="0" swAng="-5400000"/>
+                <a:lnTo>
+                  <a:pt x="76200" y="38100"/>
+                </a:lnTo>
+                <a:arcTo wR="76200" hR="38100" stAng="16200000" swAng="-5400000"/>
+                <a:close/>
+              </a:path>
+            </a:pathLst>
+          </a:custGeom>
+          <a:solidFill>
+            <a:srgbClr val="4E6596"/>
+          </a:solidFill>
+          <a:ln/>
+        </p:spPr>
+        <p:txBody>
+          <a:bodyPr/>
+          <a:lstStyle/>
+          <a:p>
+            <a:endParaRPr lang="en-US"/>
+          </a:p>
+        </p:txBody>
+      </p:sp>
+      <p:sp>
+        <p:nvSpPr>
+          <p:cNvPr id="20" name="Text 18"/>
+          <p:cNvSpPr/>
+          <p:nvPr/>
+        </p:nvSpPr>
+        <p:spPr>
+          <a:xfrm>
+            <a:off x="1041400" y="3831431"/>
+            <a:ext cx="3017317" cy="238720"/>
+          </a:xfrm>
+          <a:prstGeom prst="rect">
+            <a:avLst/>
+          </a:prstGeom>
+          <a:noFill/>
+          <a:ln/>
+        </p:spPr>
+        <p:txBody>
+          <a:bodyPr wrap="square" lIns="0" tIns="0" rIns="0" bIns="0" rtlCol="0" anchor="t">
+            <a:normAutofit/>
+          </a:bodyPr>
+          <a:lstStyle/>
+          <a:p>
+            <a:pPr marL="0" indent="0" algn="l">
+              <a:lnSpc>
+                <a:spcPts val="1680"/>
+              </a:lnSpc>
+              <a:buNone/>
+            </a:pPr>
+            <a:r>
+              <a:rPr lang="en-US" sz="1400" b="1" dirty="0">
+                <a:solidFill>
+                  <a:srgbClr val="2B2B30"/>
+                </a:solidFill>
+                <a:latin typeface="Public Sans" pitchFamily="34" charset="0"/>
+                <a:ea typeface="Public Sans" pitchFamily="34" charset="-122"/>
+                <a:cs typeface="Public Sans" pitchFamily="34" charset="-120"/>
+              </a:rPr>
+              <a:t>4 · Reshaped census data</a:t>
+            </a:r>
+            <a:endParaRPr lang="en-US" sz="1400" dirty="0"/>
+          </a:p>
+        </p:txBody>
+      </p:sp>
+      <p:sp>
+        <p:nvSpPr>
+          <p:cNvPr id="21" name="Text 19"/>
+          <p:cNvSpPr/>
+          <p:nvPr/>
+        </p:nvSpPr>
+        <p:spPr>
+          <a:xfrm>
+            <a:off x="1041400" y="4108252"/>
+            <a:ext cx="3017317" cy="346670"/>
+          </a:xfrm>
+          <a:prstGeom prst="rect">
+            <a:avLst/>
+          </a:prstGeom>
+          <a:noFill/>
+          <a:ln/>
+        </p:spPr>
+        <p:txBody>
+          <a:bodyPr wrap="square" lIns="0" tIns="0" rIns="0" bIns="0" rtlCol="0" anchor="t">
+            <a:normAutofit/>
+          </a:bodyPr>
+          <a:lstStyle/>
+          <a:p>
+            <a:pPr marL="0" indent="0" algn="l">
+              <a:lnSpc>
+                <a:spcPts val="2530"/>
+              </a:lnSpc>
+              <a:buNone/>
+            </a:pPr>
+            <a:r>
+              <a:rPr lang="en-US" sz="2200" b="1" dirty="0">
+                <a:solidFill>
+                  <a:srgbClr val="4E6596"/>
+                </a:solidFill>
+                <a:latin typeface="Libre Baskerville" pitchFamily="18" charset="0"/>
+                <a:ea typeface="Libre Baskerville" pitchFamily="18" charset="-122"/>
+                <a:cs typeface="Libre Baskerville" pitchFamily="18" charset="-120"/>
+              </a:rPr>
+              <a:t>2,091 → 113 rows</a:t>
+            </a:r>
+            <a:endParaRPr lang="en-US" sz="2200" dirty="0"/>
+          </a:p>
+        </p:txBody>
+      </p:sp>
+      <p:sp>
+        <p:nvSpPr>
+          <p:cNvPr id="22" name="Text 20"/>
+          <p:cNvSpPr/>
+          <p:nvPr/>
+        </p:nvSpPr>
+        <p:spPr>
+          <a:xfrm>
+            <a:off x="1041400" y="4493022"/>
+            <a:ext cx="3017317" cy="642590"/>
+          </a:xfrm>
+          <a:prstGeom prst="rect">
+            <a:avLst/>
+          </a:prstGeom>
+          <a:noFill/>
+          <a:ln/>
+        </p:spPr>
+        <p:txBody>
+          <a:bodyPr wrap="square" lIns="0" tIns="0" rIns="0" bIns="0" rtlCol="0" anchor="t">
+            <a:normAutofit/>
+          </a:bodyPr>
+          <a:lstStyle/>
+          <a:p>
+            <a:pPr marL="0" indent="0" algn="l">
+              <a:lnSpc>
+                <a:spcPts val="1620"/>
+              </a:lnSpc>
+              <a:buNone/>
+            </a:pPr>
+            <a:r>
+              <a:rPr lang="en-US" sz="1200" dirty="0">
+                <a:solidFill>
+                  <a:srgbClr val="4A4A52"/>
+                </a:solidFill>
+                <a:latin typeface="Public Sans" pitchFamily="34" charset="0"/>
+                <a:ea typeface="Public Sans" pitchFamily="34" charset="-122"/>
+                <a:cs typeface="Public Sans" pitchFamily="34" charset="-120"/>
+              </a:rPr>
+              <a:t>Used Python to give each area one row, with each trait as its own column, and fixed the number formats.</a:t>
+            </a:r>
+            <a:endParaRPr lang="en-US" sz="1200" dirty="0"/>
+          </a:p>
+        </p:txBody>
+      </p:sp>
+      <p:sp>
+        <p:nvSpPr>
+          <p:cNvPr id="23" name="Shape 21"/>
+          <p:cNvSpPr/>
+          <p:nvPr/>
+        </p:nvSpPr>
+        <p:spPr>
+          <a:xfrm>
+            <a:off x="4402634" y="3615531"/>
+            <a:ext cx="3386683" cy="1878211"/>
+          </a:xfrm>
+          <a:prstGeom prst="roundRect">
+            <a:avLst>
+              <a:gd name="adj" fmla="val 4057"/>
+            </a:avLst>
+          </a:prstGeom>
+          <a:solidFill>
+            <a:srgbClr val="FFFFFF"/>
+          </a:solidFill>
+          <a:ln/>
+        </p:spPr>
+        <p:txBody>
+          <a:bodyPr/>
+          <a:lstStyle/>
+          <a:p>
+            <a:endParaRPr lang="en-US"/>
+          </a:p>
+        </p:txBody>
+      </p:sp>
+      <p:sp>
+        <p:nvSpPr>
+          <p:cNvPr id="24" name="Shape 22"/>
+          <p:cNvSpPr/>
+          <p:nvPr/>
+        </p:nvSpPr>
+        <p:spPr>
+          <a:xfrm>
+            <a:off x="4402634" y="3615531"/>
+            <a:ext cx="3386683" cy="1878211"/>
+          </a:xfrm>
+          <a:custGeom>
+            <a:avLst/>
+            <a:gdLst/>
+            <a:ahLst/>
+            <a:cxnLst/>
+            <a:rect l="l" t="t" r="r" b="b"/>
+            <a:pathLst>
+              <a:path w="3386683" h="1878211">
+                <a:moveTo>
+                  <a:pt x="0" y="76200"/>
+                </a:moveTo>
+                <a:lnTo>
+                  <a:pt x="0" y="76200"/>
+                </a:lnTo>
+                <a:arcTo wR="76200" hR="76200" stAng="10800000" swAng="5400000"/>
+                <a:lnTo>
+                  <a:pt x="3310483" y="0"/>
+                </a:lnTo>
+                <a:arcTo wR="76200" hR="76200" stAng="16200000" swAng="5400000"/>
+                <a:lnTo>
+                  <a:pt x="3386683" y="76200"/>
+                </a:lnTo>
+                <a:arcTo wR="76200" hR="38100" stAng="0" swAng="-5400000"/>
+                <a:lnTo>
+                  <a:pt x="76200" y="38100"/>
+                </a:lnTo>
+                <a:arcTo wR="76200" hR="38100" stAng="16200000" swAng="-5400000"/>
+                <a:close/>
+              </a:path>
+            </a:pathLst>
+          </a:custGeom>
+          <a:solidFill>
+            <a:srgbClr val="4E6596"/>
+          </a:solidFill>
+          <a:ln/>
+        </p:spPr>
+        <p:txBody>
+          <a:bodyPr/>
+          <a:lstStyle/>
+          <a:p>
+            <a:endParaRPr lang="en-US"/>
+          </a:p>
+        </p:txBody>
+      </p:sp>
+      <p:sp>
+        <p:nvSpPr>
+          <p:cNvPr id="25" name="Text 23"/>
+          <p:cNvSpPr/>
+          <p:nvPr/>
+        </p:nvSpPr>
+        <p:spPr>
+          <a:xfrm>
+            <a:off x="4631234" y="3831431"/>
+            <a:ext cx="3017368" cy="238720"/>
+          </a:xfrm>
+          <a:prstGeom prst="rect">
+            <a:avLst/>
+          </a:prstGeom>
+          <a:noFill/>
+          <a:ln/>
+        </p:spPr>
+        <p:txBody>
+          <a:bodyPr wrap="square" lIns="0" tIns="0" rIns="0" bIns="0" rtlCol="0" anchor="t">
+            <a:normAutofit/>
+          </a:bodyPr>
+          <a:lstStyle/>
+          <a:p>
+            <a:pPr marL="0" indent="0" algn="l">
+              <a:lnSpc>
+                <a:spcPts val="1680"/>
+              </a:lnSpc>
+              <a:buNone/>
+            </a:pPr>
+            <a:r>
+              <a:rPr lang="en-US" sz="1400" b="1" dirty="0">
+                <a:solidFill>
+                  <a:srgbClr val="2B2B30"/>
+                </a:solidFill>
+                <a:latin typeface="Public Sans" pitchFamily="34" charset="0"/>
+                <a:ea typeface="Public Sans" pitchFamily="34" charset="-122"/>
+                <a:cs typeface="Public Sans" pitchFamily="34" charset="-120"/>
+              </a:rPr>
+              <a:t>5 · Linked and rated areas</a:t>
+            </a:r>
+            <a:endParaRPr lang="en-US" sz="1400" dirty="0"/>
+          </a:p>
+        </p:txBody>
+      </p:sp>
+      <p:sp>
+        <p:nvSpPr>
+          <p:cNvPr id="26" name="Text 24"/>
+          <p:cNvSpPr/>
+          <p:nvPr/>
+        </p:nvSpPr>
+        <p:spPr>
+          <a:xfrm>
+            <a:off x="4631234" y="4108252"/>
+            <a:ext cx="3017368" cy="346670"/>
+          </a:xfrm>
+          <a:prstGeom prst="rect">
+            <a:avLst/>
+          </a:prstGeom>
+          <a:noFill/>
+          <a:ln/>
+        </p:spPr>
+        <p:txBody>
+          <a:bodyPr wrap="square" lIns="0" tIns="0" rIns="0" bIns="0" rtlCol="0" anchor="t">
+            <a:normAutofit/>
+          </a:bodyPr>
+          <a:lstStyle/>
+          <a:p>
+            <a:pPr>
+              <a:lnSpc>
+                <a:spcPts val="2530"/>
+              </a:lnSpc>
+            </a:pPr>
+            <a:r>
+              <a:rPr lang="en-US" sz="2200" b="1" dirty="0">
+                <a:solidFill>
+                  <a:srgbClr val="4E6596"/>
+                </a:solidFill>
+                <a:latin typeface="Libre Baskerville" pitchFamily="18" charset="0"/>
+                <a:ea typeface="Libre Baskerville" pitchFamily="18" charset="-122"/>
+                <a:cs typeface="Libre Baskerville" pitchFamily="18" charset="-120"/>
+              </a:rPr>
+              <a:t>307 → 113</a:t>
+            </a:r>
+            <a:endParaRPr lang="en-US" sz="2200" dirty="0"/>
+          </a:p>
+        </p:txBody>
+      </p:sp>
+      <p:sp>
+        <p:nvSpPr>
+          <p:cNvPr id="27" name="Text 25"/>
+          <p:cNvSpPr/>
+          <p:nvPr/>
+        </p:nvSpPr>
+        <p:spPr>
+          <a:xfrm>
+            <a:off x="4631234" y="4493022"/>
+            <a:ext cx="3017368" cy="848320"/>
+          </a:xfrm>
+          <a:prstGeom prst="rect">
+            <a:avLst/>
+          </a:prstGeom>
+          <a:noFill/>
+          <a:ln/>
+        </p:spPr>
+        <p:txBody>
+          <a:bodyPr wrap="square" lIns="0" tIns="0" rIns="0" bIns="0" rtlCol="0" anchor="t">
+            <a:normAutofit/>
+          </a:bodyPr>
+          <a:lstStyle/>
+          <a:p>
+            <a:pPr marL="0" indent="0" algn="l">
+              <a:lnSpc>
+                <a:spcPts val="1620"/>
+              </a:lnSpc>
+              <a:buNone/>
+            </a:pPr>
+            <a:r>
+              <a:rPr lang="en-US" sz="1200" dirty="0">
+                <a:solidFill>
+                  <a:srgbClr val="4A4A52"/>
+                </a:solidFill>
+                <a:latin typeface="Public Sans" pitchFamily="34" charset="0"/>
+                <a:ea typeface="Public Sans" pitchFamily="34" charset="-122"/>
+                <a:cs typeface="Public Sans" pitchFamily="34" charset="-120"/>
+              </a:rPr>
+              <a:t>Each incident has both its community (307) and its area (113), which links the two. Then: incidents per 1,000 residents a year.</a:t>
+            </a:r>
+            <a:endParaRPr lang="en-US" sz="1200" dirty="0"/>
+          </a:p>
+        </p:txBody>
+      </p:sp>
+      <p:sp>
+        <p:nvSpPr>
+          <p:cNvPr id="28" name="Shape 26"/>
+          <p:cNvSpPr/>
+          <p:nvPr/>
+        </p:nvSpPr>
+        <p:spPr>
+          <a:xfrm>
+            <a:off x="7992517" y="3615531"/>
+            <a:ext cx="3386634" cy="1878211"/>
+          </a:xfrm>
+          <a:prstGeom prst="roundRect">
+            <a:avLst>
+              <a:gd name="adj" fmla="val 4057"/>
+            </a:avLst>
+          </a:prstGeom>
+          <a:solidFill>
+            <a:srgbClr val="FFFFFF"/>
+          </a:solidFill>
+          <a:ln/>
+        </p:spPr>
+        <p:txBody>
+          <a:bodyPr/>
+          <a:lstStyle/>
+          <a:p>
+            <a:endParaRPr lang="en-US"/>
+          </a:p>
+        </p:txBody>
+      </p:sp>
+      <p:sp>
+        <p:nvSpPr>
+          <p:cNvPr id="29" name="Shape 27"/>
+          <p:cNvSpPr/>
+          <p:nvPr/>
+        </p:nvSpPr>
+        <p:spPr>
+          <a:xfrm>
+            <a:off x="7992517" y="3615531"/>
+            <a:ext cx="3386634" cy="1878211"/>
+          </a:xfrm>
+          <a:custGeom>
+            <a:avLst/>
+            <a:gdLst/>
+            <a:ahLst/>
+            <a:cxnLst/>
+            <a:rect l="l" t="t" r="r" b="b"/>
+            <a:pathLst>
+              <a:path w="3386634" h="1878211">
+                <a:moveTo>
+                  <a:pt x="0" y="76200"/>
+                </a:moveTo>
+                <a:lnTo>
+                  <a:pt x="0" y="76200"/>
+                </a:lnTo>
+                <a:arcTo wR="76200" hR="76200" stAng="10800000" swAng="5400000"/>
+                <a:lnTo>
+                  <a:pt x="3310434" y="0"/>
+                </a:lnTo>
+                <a:arcTo wR="76200" hR="76200" stAng="16200000" swAng="5400000"/>
+                <a:lnTo>
+                  <a:pt x="3386634" y="76200"/>
+                </a:lnTo>
+                <a:arcTo wR="76200" hR="38100" stAng="0" swAng="-5400000"/>
+                <a:lnTo>
+                  <a:pt x="76200" y="38100"/>
+                </a:lnTo>
+                <a:arcTo wR="76200" hR="38100" stAng="16200000" swAng="-5400000"/>
+                <a:close/>
+              </a:path>
+            </a:pathLst>
+          </a:custGeom>
+          <a:solidFill>
+            <a:srgbClr val="4E6596"/>
+          </a:solidFill>
+          <a:ln/>
+        </p:spPr>
+        <p:txBody>
+          <a:bodyPr/>
+          <a:lstStyle/>
+          <a:p>
+            <a:endParaRPr lang="en-US"/>
+          </a:p>
+        </p:txBody>
+      </p:sp>
+      <p:sp>
+        <p:nvSpPr>
+          <p:cNvPr id="30" name="Text 28"/>
+          <p:cNvSpPr/>
+          <p:nvPr/>
+        </p:nvSpPr>
+        <p:spPr>
+          <a:xfrm>
+            <a:off x="8221117" y="3831431"/>
+            <a:ext cx="3017317" cy="238720"/>
+          </a:xfrm>
+          <a:prstGeom prst="rect">
+            <a:avLst/>
+          </a:prstGeom>
+          <a:noFill/>
+          <a:ln/>
+        </p:spPr>
+        <p:txBody>
+          <a:bodyPr wrap="square" lIns="0" tIns="0" rIns="0" bIns="0" rtlCol="0" anchor="t">
+            <a:normAutofit/>
+          </a:bodyPr>
+          <a:lstStyle/>
+          <a:p>
+            <a:pPr marL="0" indent="0" algn="l">
+              <a:lnSpc>
+                <a:spcPts val="1680"/>
+              </a:lnSpc>
+              <a:buNone/>
+            </a:pPr>
+            <a:r>
+              <a:rPr lang="en-US" sz="1400" b="1" dirty="0">
+                <a:solidFill>
+                  <a:srgbClr val="2B2B30"/>
+                </a:solidFill>
+                <a:latin typeface="Public Sans" pitchFamily="34" charset="0"/>
+                <a:ea typeface="Public Sans" pitchFamily="34" charset="-122"/>
+                <a:cs typeface="Public Sans" pitchFamily="34" charset="-120"/>
+              </a:rPr>
+              <a:t>6 · Key measures in DAX</a:t>
+            </a:r>
+            <a:endParaRPr lang="en-US" sz="1400" dirty="0"/>
+          </a:p>
+        </p:txBody>
+      </p:sp>
+      <p:sp>
+        <p:nvSpPr>
+          <p:cNvPr id="31" name="Text 29"/>
+          <p:cNvSpPr/>
+          <p:nvPr/>
+        </p:nvSpPr>
+        <p:spPr>
+          <a:xfrm>
+            <a:off x="8221117" y="4108252"/>
+            <a:ext cx="3017317" cy="346670"/>
+          </a:xfrm>
+          <a:prstGeom prst="rect">
+            <a:avLst/>
+          </a:prstGeom>
+          <a:noFill/>
+          <a:ln/>
+        </p:spPr>
+        <p:txBody>
+          <a:bodyPr wrap="square" lIns="0" tIns="0" rIns="0" bIns="0" rtlCol="0" anchor="t">
+            <a:normAutofit/>
+          </a:bodyPr>
+          <a:lstStyle/>
+          <a:p>
+            <a:pPr marL="0" indent="0" algn="l">
+              <a:lnSpc>
+                <a:spcPts val="2530"/>
+              </a:lnSpc>
+              <a:buNone/>
+            </a:pPr>
+            <a:r>
+              <a:rPr lang="en-US" sz="2200" b="1" dirty="0">
+                <a:solidFill>
+                  <a:srgbClr val="4E6596"/>
+                </a:solidFill>
+                <a:latin typeface="Libre Baskerville" pitchFamily="18" charset="0"/>
+                <a:ea typeface="Libre Baskerville" pitchFamily="18" charset="-122"/>
+                <a:cs typeface="Libre Baskerville" pitchFamily="18" charset="-120"/>
+              </a:rPr>
+              <a:t>Rows → measures</a:t>
+            </a:r>
+            <a:endParaRPr lang="en-US" sz="2200" dirty="0"/>
+          </a:p>
+        </p:txBody>
+      </p:sp>
+      <p:sp>
+        <p:nvSpPr>
+          <p:cNvPr id="32" name="Text 30"/>
+          <p:cNvSpPr/>
+          <p:nvPr/>
+        </p:nvSpPr>
+        <p:spPr>
+          <a:xfrm>
+            <a:off x="8221117" y="4493022"/>
+            <a:ext cx="3017317" cy="642590"/>
+          </a:xfrm>
+          <a:prstGeom prst="rect">
+            <a:avLst/>
+          </a:prstGeom>
+          <a:noFill/>
+          <a:ln/>
+        </p:spPr>
+        <p:txBody>
+          <a:bodyPr wrap="square" lIns="0" tIns="0" rIns="0" bIns="0" rtlCol="0" anchor="t">
+            <a:normAutofit/>
+          </a:bodyPr>
+          <a:lstStyle/>
+          <a:p>
+            <a:pPr marL="0" indent="0" algn="l">
+              <a:lnSpc>
+                <a:spcPts val="1620"/>
+              </a:lnSpc>
+              <a:buNone/>
+            </a:pPr>
+            <a:r>
+              <a:rPr lang="en-US" sz="1200" dirty="0">
+                <a:solidFill>
+                  <a:srgbClr val="4A4A52"/>
+                </a:solidFill>
+                <a:latin typeface="Public Sans" pitchFamily="34" charset="0"/>
+                <a:ea typeface="Public Sans" pitchFamily="34" charset="-122"/>
+                <a:cs typeface="Public Sans" pitchFamily="34" charset="-120"/>
+              </a:rPr>
+              <a:t>DAX turns raw rows into numbers that update with every click, like rate vs. city average and the busiest hour.</a:t>
+            </a:r>
+            <a:endParaRPr lang="en-US" sz="1200" dirty="0"/>
+          </a:p>
+        </p:txBody>
+      </p:sp>
+    </p:spTree>
+  </p:cSld>
+  <p:clrMapOvr>
+    <a:masterClrMapping/>
+  </p:clrMapOvr>
+</p:sld>
+</file>
+
+<file path=ppt/slides/slide7.xml><?xml version="1.0" encoding="utf-8"?>
+<p:sld xmlns:a="http://schemas.openxmlformats.org/drawingml/2006/main" xmlns:r="http://schemas.openxmlformats.org/officeDocument/2006/relationships" xmlns:p="http://schemas.openxmlformats.org/presentationml/2006/main">
+  <p:cSld>
     <p:bg>
       <p:bgPr>
         <a:solidFill>
@@ -6908,7 +9228,7 @@
 </p:sld>
 </file>
 
-<file path=ppt/slides/slide7.xml><?xml version="1.0" encoding="utf-8"?>
+<file path=ppt/slides/slide8.xml><?xml version="1.0" encoding="utf-8"?>
 <p:sld xmlns:a="http://schemas.openxmlformats.org/drawingml/2006/main" xmlns:r="http://schemas.openxmlformats.org/officeDocument/2006/relationships" xmlns:p="http://schemas.openxmlformats.org/presentationml/2006/main">
   <p:cSld>
     <p:spTree>
@@ -7663,7 +9983,7 @@
 </p:sld>
 </file>
 
-<file path=ppt/slides/slide8.xml><?xml version="1.0" encoding="utf-8"?>
+<file path=ppt/slides/slide9.xml><?xml version="1.0" encoding="utf-8"?>
 <p:sld xmlns:a="http://schemas.openxmlformats.org/drawingml/2006/main" xmlns:r="http://schemas.openxmlformats.org/officeDocument/2006/relationships" xmlns:p="http://schemas.openxmlformats.org/presentationml/2006/main">
   <p:cSld name="Slide 8">
     <p:spTree>
@@ -7868,730 +10188,6 @@
               <a:t> (55.5 vs. 35.0 per 100,000 residents a month). Fall and winter sit above average.</a:t>
             </a:r>
             <a:endParaRPr lang="en-US" sz="1700" dirty="0"/>
-          </a:p>
-        </p:txBody>
-      </p:sp>
-    </p:spTree>
-  </p:cSld>
-  <p:clrMapOvr>
-    <a:masterClrMapping/>
-  </p:clrMapOvr>
-</p:sld>
-</file>
-
-<file path=ppt/slides/slide9.xml><?xml version="1.0" encoding="utf-8"?>
-<p:sld xmlns:a="http://schemas.openxmlformats.org/drawingml/2006/main" xmlns:r="http://schemas.openxmlformats.org/officeDocument/2006/relationships" xmlns:p="http://schemas.openxmlformats.org/presentationml/2006/main">
-  <p:cSld>
-    <p:bg>
-      <p:bgPr>
-        <a:solidFill>
-          <a:srgbClr val="2B2B30"/>
-        </a:solidFill>
-        <a:effectLst/>
-      </p:bgPr>
-    </p:bg>
-    <p:spTree>
-      <p:nvGrpSpPr>
-        <p:cNvPr id="1" name=""/>
-        <p:cNvGrpSpPr/>
-        <p:nvPr/>
-      </p:nvGrpSpPr>
-      <p:grpSpPr>
-        <a:xfrm>
-          <a:off x="0" y="0"/>
-          <a:ext cx="0" cy="0"/>
-          <a:chOff x="0" y="0"/>
-          <a:chExt cx="0" cy="0"/>
-        </a:xfrm>
-      </p:grpSpPr>
-      <p:sp>
-        <p:nvSpPr>
-          <p:cNvPr id="2" name="Shape 0"/>
-          <p:cNvSpPr/>
-          <p:nvPr/>
-        </p:nvSpPr>
-        <p:spPr>
-          <a:xfrm>
-            <a:off x="8686800" y="1905000"/>
-            <a:ext cx="863600" cy="863600"/>
-          </a:xfrm>
-          <a:prstGeom prst="rect">
-            <a:avLst/>
-          </a:prstGeom>
-          <a:solidFill>
-            <a:srgbClr val="D47BA3"/>
-          </a:solidFill>
-          <a:ln/>
-        </p:spPr>
-        <p:txBody>
-          <a:bodyPr/>
-          <a:lstStyle/>
-          <a:p>
-            <a:pPr marL="0" marR="0" lvl="0" indent="0" algn="l" defTabSz="914400" rtl="0" eaLnBrk="1" fontAlgn="auto" latinLnBrk="0" hangingPunct="1">
-              <a:lnSpc>
-                <a:spcPct val="100000"/>
-              </a:lnSpc>
-              <a:spcBef>
-                <a:spcPts val="0"/>
-              </a:spcBef>
-              <a:spcAft>
-                <a:spcPts val="0"/>
-              </a:spcAft>
-              <a:buClrTx/>
-              <a:buSzTx/>
-              <a:buFontTx/>
-              <a:buNone/>
-              <a:tabLst/>
-              <a:defRPr/>
-            </a:pPr>
-            <a:endParaRPr kumimoji="0" lang="en-CA" sz="1800" b="0" i="0" u="none" strike="noStrike" kern="1200" cap="none" spc="0" normalizeH="0" baseline="0" noProof="0">
-              <a:ln>
-                <a:noFill/>
-              </a:ln>
-              <a:solidFill>
-                <a:srgbClr val="2B2B30"/>
-              </a:solidFill>
-              <a:effectLst/>
-              <a:uLnTx/>
-              <a:uFillTx/>
-              <a:latin typeface="Public Sans"/>
-              <a:ea typeface="+mn-ea"/>
-              <a:cs typeface="+mn-cs"/>
-            </a:endParaRPr>
-          </a:p>
-        </p:txBody>
-      </p:sp>
-      <p:sp>
-        <p:nvSpPr>
-          <p:cNvPr id="3" name="Shape 1"/>
-          <p:cNvSpPr/>
-          <p:nvPr/>
-        </p:nvSpPr>
-        <p:spPr>
-          <a:xfrm>
-            <a:off x="9601200" y="1905000"/>
-            <a:ext cx="863600" cy="863600"/>
-          </a:xfrm>
-          <a:prstGeom prst="rect">
-            <a:avLst/>
-          </a:prstGeom>
-          <a:solidFill>
-            <a:srgbClr val="9E6B92"/>
-          </a:solidFill>
-          <a:ln/>
-        </p:spPr>
-        <p:txBody>
-          <a:bodyPr/>
-          <a:lstStyle/>
-          <a:p>
-            <a:pPr marL="0" marR="0" lvl="0" indent="0" algn="l" defTabSz="914400" rtl="0" eaLnBrk="1" fontAlgn="auto" latinLnBrk="0" hangingPunct="1">
-              <a:lnSpc>
-                <a:spcPct val="100000"/>
-              </a:lnSpc>
-              <a:spcBef>
-                <a:spcPts val="0"/>
-              </a:spcBef>
-              <a:spcAft>
-                <a:spcPts val="0"/>
-              </a:spcAft>
-              <a:buClrTx/>
-              <a:buSzTx/>
-              <a:buFontTx/>
-              <a:buNone/>
-              <a:tabLst/>
-              <a:defRPr/>
-            </a:pPr>
-            <a:endParaRPr kumimoji="0" lang="en-CA" sz="1800" b="0" i="0" u="none" strike="noStrike" kern="1200" cap="none" spc="0" normalizeH="0" baseline="0" noProof="0">
-              <a:ln>
-                <a:noFill/>
-              </a:ln>
-              <a:solidFill>
-                <a:srgbClr val="2B2B30"/>
-              </a:solidFill>
-              <a:effectLst/>
-              <a:uLnTx/>
-              <a:uFillTx/>
-              <a:latin typeface="Public Sans"/>
-              <a:ea typeface="+mn-ea"/>
-              <a:cs typeface="+mn-cs"/>
-            </a:endParaRPr>
-          </a:p>
-        </p:txBody>
-      </p:sp>
-      <p:sp>
-        <p:nvSpPr>
-          <p:cNvPr id="4" name="Shape 2"/>
-          <p:cNvSpPr/>
-          <p:nvPr/>
-        </p:nvSpPr>
-        <p:spPr>
-          <a:xfrm>
-            <a:off x="10515600" y="1905000"/>
-            <a:ext cx="863600" cy="863600"/>
-          </a:xfrm>
-          <a:prstGeom prst="rect">
-            <a:avLst/>
-          </a:prstGeom>
-          <a:solidFill>
-            <a:srgbClr val="4A4A78"/>
-          </a:solidFill>
-          <a:ln/>
-        </p:spPr>
-        <p:txBody>
-          <a:bodyPr/>
-          <a:lstStyle/>
-          <a:p>
-            <a:pPr marL="0" marR="0" lvl="0" indent="0" algn="l" defTabSz="914400" rtl="0" eaLnBrk="1" fontAlgn="auto" latinLnBrk="0" hangingPunct="1">
-              <a:lnSpc>
-                <a:spcPct val="100000"/>
-              </a:lnSpc>
-              <a:spcBef>
-                <a:spcPts val="0"/>
-              </a:spcBef>
-              <a:spcAft>
-                <a:spcPts val="0"/>
-              </a:spcAft>
-              <a:buClrTx/>
-              <a:buSzTx/>
-              <a:buFontTx/>
-              <a:buNone/>
-              <a:tabLst/>
-              <a:defRPr/>
-            </a:pPr>
-            <a:endParaRPr kumimoji="0" lang="en-CA" sz="1800" b="0" i="0" u="none" strike="noStrike" kern="1200" cap="none" spc="0" normalizeH="0" baseline="0" noProof="0">
-              <a:ln>
-                <a:noFill/>
-              </a:ln>
-              <a:solidFill>
-                <a:srgbClr val="2B2B30"/>
-              </a:solidFill>
-              <a:effectLst/>
-              <a:uLnTx/>
-              <a:uFillTx/>
-              <a:latin typeface="Public Sans"/>
-              <a:ea typeface="+mn-ea"/>
-              <a:cs typeface="+mn-cs"/>
-            </a:endParaRPr>
-          </a:p>
-        </p:txBody>
-      </p:sp>
-      <p:sp>
-        <p:nvSpPr>
-          <p:cNvPr id="5" name="Shape 3"/>
-          <p:cNvSpPr/>
-          <p:nvPr/>
-        </p:nvSpPr>
-        <p:spPr>
-          <a:xfrm>
-            <a:off x="8686800" y="2819400"/>
-            <a:ext cx="863600" cy="863600"/>
-          </a:xfrm>
-          <a:prstGeom prst="rect">
-            <a:avLst/>
-          </a:prstGeom>
-          <a:solidFill>
-            <a:srgbClr val="DBB7CF"/>
-          </a:solidFill>
-          <a:ln/>
-        </p:spPr>
-        <p:txBody>
-          <a:bodyPr/>
-          <a:lstStyle/>
-          <a:p>
-            <a:pPr marL="0" marR="0" lvl="0" indent="0" algn="l" defTabSz="914400" rtl="0" eaLnBrk="1" fontAlgn="auto" latinLnBrk="0" hangingPunct="1">
-              <a:lnSpc>
-                <a:spcPct val="100000"/>
-              </a:lnSpc>
-              <a:spcBef>
-                <a:spcPts val="0"/>
-              </a:spcBef>
-              <a:spcAft>
-                <a:spcPts val="0"/>
-              </a:spcAft>
-              <a:buClrTx/>
-              <a:buSzTx/>
-              <a:buFontTx/>
-              <a:buNone/>
-              <a:tabLst/>
-              <a:defRPr/>
-            </a:pPr>
-            <a:endParaRPr kumimoji="0" lang="en-CA" sz="1800" b="0" i="0" u="none" strike="noStrike" kern="1200" cap="none" spc="0" normalizeH="0" baseline="0" noProof="0">
-              <a:ln>
-                <a:noFill/>
-              </a:ln>
-              <a:solidFill>
-                <a:srgbClr val="2B2B30"/>
-              </a:solidFill>
-              <a:effectLst/>
-              <a:uLnTx/>
-              <a:uFillTx/>
-              <a:latin typeface="Public Sans"/>
-              <a:ea typeface="+mn-ea"/>
-              <a:cs typeface="+mn-cs"/>
-            </a:endParaRPr>
-          </a:p>
-        </p:txBody>
-      </p:sp>
-      <p:sp>
-        <p:nvSpPr>
-          <p:cNvPr id="6" name="Shape 4"/>
-          <p:cNvSpPr/>
-          <p:nvPr/>
-        </p:nvSpPr>
-        <p:spPr>
-          <a:xfrm>
-            <a:off x="9601200" y="2819400"/>
-            <a:ext cx="863600" cy="863600"/>
-          </a:xfrm>
-          <a:prstGeom prst="rect">
-            <a:avLst/>
-          </a:prstGeom>
-          <a:solidFill>
-            <a:srgbClr val="A3A3C8"/>
-          </a:solidFill>
-          <a:ln/>
-        </p:spPr>
-        <p:txBody>
-          <a:bodyPr/>
-          <a:lstStyle/>
-          <a:p>
-            <a:pPr marL="0" marR="0" lvl="0" indent="0" algn="l" defTabSz="914400" rtl="0" eaLnBrk="1" fontAlgn="auto" latinLnBrk="0" hangingPunct="1">
-              <a:lnSpc>
-                <a:spcPct val="100000"/>
-              </a:lnSpc>
-              <a:spcBef>
-                <a:spcPts val="0"/>
-              </a:spcBef>
-              <a:spcAft>
-                <a:spcPts val="0"/>
-              </a:spcAft>
-              <a:buClrTx/>
-              <a:buSzTx/>
-              <a:buFontTx/>
-              <a:buNone/>
-              <a:tabLst/>
-              <a:defRPr/>
-            </a:pPr>
-            <a:endParaRPr kumimoji="0" lang="en-CA" sz="1800" b="0" i="0" u="none" strike="noStrike" kern="1200" cap="none" spc="0" normalizeH="0" baseline="0" noProof="0">
-              <a:ln>
-                <a:noFill/>
-              </a:ln>
-              <a:solidFill>
-                <a:srgbClr val="2B2B30"/>
-              </a:solidFill>
-              <a:effectLst/>
-              <a:uLnTx/>
-              <a:uFillTx/>
-              <a:latin typeface="Public Sans"/>
-              <a:ea typeface="+mn-ea"/>
-              <a:cs typeface="+mn-cs"/>
-            </a:endParaRPr>
-          </a:p>
-        </p:txBody>
-      </p:sp>
-      <p:sp>
-        <p:nvSpPr>
-          <p:cNvPr id="7" name="Shape 5"/>
-          <p:cNvSpPr/>
-          <p:nvPr/>
-        </p:nvSpPr>
-        <p:spPr>
-          <a:xfrm>
-            <a:off x="10515600" y="2819400"/>
-            <a:ext cx="863600" cy="863600"/>
-          </a:xfrm>
-          <a:prstGeom prst="rect">
-            <a:avLst/>
-          </a:prstGeom>
-          <a:solidFill>
-            <a:srgbClr val="56709E"/>
-          </a:solidFill>
-          <a:ln/>
-        </p:spPr>
-        <p:txBody>
-          <a:bodyPr/>
-          <a:lstStyle/>
-          <a:p>
-            <a:pPr marL="0" marR="0" lvl="0" indent="0" algn="l" defTabSz="914400" rtl="0" eaLnBrk="1" fontAlgn="auto" latinLnBrk="0" hangingPunct="1">
-              <a:lnSpc>
-                <a:spcPct val="100000"/>
-              </a:lnSpc>
-              <a:spcBef>
-                <a:spcPts val="0"/>
-              </a:spcBef>
-              <a:spcAft>
-                <a:spcPts val="0"/>
-              </a:spcAft>
-              <a:buClrTx/>
-              <a:buSzTx/>
-              <a:buFontTx/>
-              <a:buNone/>
-              <a:tabLst/>
-              <a:defRPr/>
-            </a:pPr>
-            <a:endParaRPr kumimoji="0" lang="en-CA" sz="1800" b="0" i="0" u="none" strike="noStrike" kern="1200" cap="none" spc="0" normalizeH="0" baseline="0" noProof="0">
-              <a:ln>
-                <a:noFill/>
-              </a:ln>
-              <a:solidFill>
-                <a:srgbClr val="2B2B30"/>
-              </a:solidFill>
-              <a:effectLst/>
-              <a:uLnTx/>
-              <a:uFillTx/>
-              <a:latin typeface="Public Sans"/>
-              <a:ea typeface="+mn-ea"/>
-              <a:cs typeface="+mn-cs"/>
-            </a:endParaRPr>
-          </a:p>
-        </p:txBody>
-      </p:sp>
-      <p:sp>
-        <p:nvSpPr>
-          <p:cNvPr id="8" name="Shape 6"/>
-          <p:cNvSpPr/>
-          <p:nvPr/>
-        </p:nvSpPr>
-        <p:spPr>
-          <a:xfrm>
-            <a:off x="8686800" y="3733800"/>
-            <a:ext cx="863600" cy="863600"/>
-          </a:xfrm>
-          <a:prstGeom prst="rect">
-            <a:avLst/>
-          </a:prstGeom>
-          <a:solidFill>
-            <a:srgbClr val="EAE1D2"/>
-          </a:solidFill>
-          <a:ln/>
-        </p:spPr>
-        <p:txBody>
-          <a:bodyPr/>
-          <a:lstStyle/>
-          <a:p>
-            <a:pPr marL="0" marR="0" lvl="0" indent="0" algn="l" defTabSz="914400" rtl="0" eaLnBrk="1" fontAlgn="auto" latinLnBrk="0" hangingPunct="1">
-              <a:lnSpc>
-                <a:spcPct val="100000"/>
-              </a:lnSpc>
-              <a:spcBef>
-                <a:spcPts val="0"/>
-              </a:spcBef>
-              <a:spcAft>
-                <a:spcPts val="0"/>
-              </a:spcAft>
-              <a:buClrTx/>
-              <a:buSzTx/>
-              <a:buFontTx/>
-              <a:buNone/>
-              <a:tabLst/>
-              <a:defRPr/>
-            </a:pPr>
-            <a:endParaRPr kumimoji="0" lang="en-CA" sz="1800" b="0" i="0" u="none" strike="noStrike" kern="1200" cap="none" spc="0" normalizeH="0" baseline="0" noProof="0">
-              <a:ln>
-                <a:noFill/>
-              </a:ln>
-              <a:solidFill>
-                <a:srgbClr val="2B2B30"/>
-              </a:solidFill>
-              <a:effectLst/>
-              <a:uLnTx/>
-              <a:uFillTx/>
-              <a:latin typeface="Public Sans"/>
-              <a:ea typeface="+mn-ea"/>
-              <a:cs typeface="+mn-cs"/>
-            </a:endParaRPr>
-          </a:p>
-        </p:txBody>
-      </p:sp>
-      <p:sp>
-        <p:nvSpPr>
-          <p:cNvPr id="9" name="Shape 7"/>
-          <p:cNvSpPr/>
-          <p:nvPr/>
-        </p:nvSpPr>
-        <p:spPr>
-          <a:xfrm>
-            <a:off x="9601200" y="3733800"/>
-            <a:ext cx="863600" cy="863600"/>
-          </a:xfrm>
-          <a:prstGeom prst="rect">
-            <a:avLst/>
-          </a:prstGeom>
-          <a:solidFill>
-            <a:srgbClr val="B5C0DA"/>
-          </a:solidFill>
-          <a:ln/>
-        </p:spPr>
-        <p:txBody>
-          <a:bodyPr/>
-          <a:lstStyle/>
-          <a:p>
-            <a:pPr marL="0" marR="0" lvl="0" indent="0" algn="l" defTabSz="914400" rtl="0" eaLnBrk="1" fontAlgn="auto" latinLnBrk="0" hangingPunct="1">
-              <a:lnSpc>
-                <a:spcPct val="100000"/>
-              </a:lnSpc>
-              <a:spcBef>
-                <a:spcPts val="0"/>
-              </a:spcBef>
-              <a:spcAft>
-                <a:spcPts val="0"/>
-              </a:spcAft>
-              <a:buClrTx/>
-              <a:buSzTx/>
-              <a:buFontTx/>
-              <a:buNone/>
-              <a:tabLst/>
-              <a:defRPr/>
-            </a:pPr>
-            <a:endParaRPr kumimoji="0" lang="en-CA" sz="1800" b="0" i="0" u="none" strike="noStrike" kern="1200" cap="none" spc="0" normalizeH="0" baseline="0" noProof="0">
-              <a:ln>
-                <a:noFill/>
-              </a:ln>
-              <a:solidFill>
-                <a:srgbClr val="2B2B30"/>
-              </a:solidFill>
-              <a:effectLst/>
-              <a:uLnTx/>
-              <a:uFillTx/>
-              <a:latin typeface="Public Sans"/>
-              <a:ea typeface="+mn-ea"/>
-              <a:cs typeface="+mn-cs"/>
-            </a:endParaRPr>
-          </a:p>
-        </p:txBody>
-      </p:sp>
-      <p:sp>
-        <p:nvSpPr>
-          <p:cNvPr id="10" name="Shape 8"/>
-          <p:cNvSpPr/>
-          <p:nvPr/>
-        </p:nvSpPr>
-        <p:spPr>
-          <a:xfrm>
-            <a:off x="10515600" y="3733800"/>
-            <a:ext cx="863600" cy="863600"/>
-          </a:xfrm>
-          <a:prstGeom prst="rect">
-            <a:avLst/>
-          </a:prstGeom>
-          <a:solidFill>
-            <a:srgbClr val="6C83B5"/>
-          </a:solidFill>
-          <a:ln/>
-        </p:spPr>
-        <p:txBody>
-          <a:bodyPr/>
-          <a:lstStyle/>
-          <a:p>
-            <a:pPr marL="0" marR="0" lvl="0" indent="0" algn="l" defTabSz="914400" rtl="0" eaLnBrk="1" fontAlgn="auto" latinLnBrk="0" hangingPunct="1">
-              <a:lnSpc>
-                <a:spcPct val="100000"/>
-              </a:lnSpc>
-              <a:spcBef>
-                <a:spcPts val="0"/>
-              </a:spcBef>
-              <a:spcAft>
-                <a:spcPts val="0"/>
-              </a:spcAft>
-              <a:buClrTx/>
-              <a:buSzTx/>
-              <a:buFontTx/>
-              <a:buNone/>
-              <a:tabLst/>
-              <a:defRPr/>
-            </a:pPr>
-            <a:endParaRPr kumimoji="0" lang="en-CA" sz="1800" b="0" i="0" u="none" strike="noStrike" kern="1200" cap="none" spc="0" normalizeH="0" baseline="0" noProof="0">
-              <a:ln>
-                <a:noFill/>
-              </a:ln>
-              <a:solidFill>
-                <a:srgbClr val="2B2B30"/>
-              </a:solidFill>
-              <a:effectLst/>
-              <a:uLnTx/>
-              <a:uFillTx/>
-              <a:latin typeface="Public Sans"/>
-              <a:ea typeface="+mn-ea"/>
-              <a:cs typeface="+mn-cs"/>
-            </a:endParaRPr>
-          </a:p>
-        </p:txBody>
-      </p:sp>
-      <p:sp>
-        <p:nvSpPr>
-          <p:cNvPr id="11" name="Text 9"/>
-          <p:cNvSpPr>
-            <a:spLocks noGrp="1"/>
-          </p:cNvSpPr>
-          <p:nvPr>
-            <p:ph type="title"/>
-          </p:nvPr>
-        </p:nvSpPr>
-        <p:spPr>
-          <a:xfrm>
-            <a:off x="812800" y="2771142"/>
-            <a:ext cx="7194550" cy="695960"/>
-          </a:xfrm>
-          <a:prstGeom prst="rect">
-            <a:avLst/>
-          </a:prstGeom>
-          <a:noFill/>
-          <a:ln/>
-        </p:spPr>
-        <p:txBody>
-          <a:bodyPr wrap="square" lIns="0" tIns="0" rIns="0" bIns="0" rtlCol="0" anchor="t">
-            <a:normAutofit/>
-          </a:bodyPr>
-          <a:lstStyle/>
-          <a:p>
-            <a:pPr marL="0" indent="0" algn="l">
-              <a:lnSpc>
-                <a:spcPts val="5280"/>
-              </a:lnSpc>
-              <a:buNone/>
-            </a:pPr>
-            <a:r>
-              <a:rPr lang="en-US" sz="4800" b="1" i="0" dirty="0">
-                <a:solidFill>
-                  <a:srgbClr val="F4EEE3"/>
-                </a:solidFill>
-                <a:latin typeface="Libre Baskerville" pitchFamily="18" charset="0"/>
-                <a:ea typeface="Libre Baskerville" pitchFamily="18" charset="-122"/>
-                <a:cs typeface="Libre Baskerville" pitchFamily="18" charset="-120"/>
-              </a:rPr>
-              <a:t>Thank you</a:t>
-            </a:r>
-            <a:endParaRPr lang="en-US" sz="4800" dirty="0"/>
-          </a:p>
-        </p:txBody>
-      </p:sp>
-      <p:sp>
-        <p:nvSpPr>
-          <p:cNvPr id="12" name="Text 10"/>
-          <p:cNvSpPr/>
-          <p:nvPr/>
-        </p:nvSpPr>
-        <p:spPr>
-          <a:xfrm>
-            <a:off x="812800" y="3695700"/>
-            <a:ext cx="7194550" cy="416560"/>
-          </a:xfrm>
-          <a:prstGeom prst="rect">
-            <a:avLst/>
-          </a:prstGeom>
-          <a:noFill/>
-          <a:ln/>
-        </p:spPr>
-        <p:txBody>
-          <a:bodyPr wrap="square" lIns="0" tIns="0" rIns="0" bIns="0" rtlCol="0" anchor="t">
-            <a:normAutofit/>
-          </a:bodyPr>
-          <a:lstStyle/>
-          <a:p>
-            <a:pPr marL="0" marR="0" lvl="0" indent="0" algn="l" defTabSz="914400" rtl="0" eaLnBrk="1" fontAlgn="auto" latinLnBrk="0" hangingPunct="1">
-              <a:lnSpc>
-                <a:spcPts val="3080"/>
-              </a:lnSpc>
-              <a:spcBef>
-                <a:spcPts val="0"/>
-              </a:spcBef>
-              <a:spcAft>
-                <a:spcPts val="0"/>
-              </a:spcAft>
-              <a:buClrTx/>
-              <a:buSzTx/>
-              <a:buFontTx/>
-              <a:buNone/>
-              <a:tabLst/>
-              <a:defRPr/>
-            </a:pPr>
-            <a:r>
-              <a:rPr kumimoji="0" lang="en-US" sz="2200" b="0" i="0" u="none" strike="noStrike" kern="1200" cap="none" spc="0" normalizeH="0" baseline="0" noProof="0" dirty="0">
-                <a:ln>
-                  <a:noFill/>
-                </a:ln>
-                <a:solidFill>
-                  <a:srgbClr val="E39BBE"/>
-                </a:solidFill>
-                <a:effectLst/>
-                <a:uLnTx/>
-                <a:uFillTx/>
-                <a:latin typeface="Public Sans" pitchFamily="34" charset="0"/>
-                <a:ea typeface="Public Sans" pitchFamily="34" charset="-122"/>
-                <a:cs typeface="Public Sans" pitchFamily="34" charset="-120"/>
-              </a:rPr>
-              <a:t>Questions?</a:t>
-            </a:r>
-            <a:endParaRPr kumimoji="0" lang="en-US" sz="2200" b="0" i="0" u="none" strike="noStrike" kern="1200" cap="none" spc="0" normalizeH="0" baseline="0" noProof="0" dirty="0">
-              <a:ln>
-                <a:noFill/>
-              </a:ln>
-              <a:solidFill>
-                <a:srgbClr val="2B2B30"/>
-              </a:solidFill>
-              <a:effectLst/>
-              <a:uLnTx/>
-              <a:uFillTx/>
-              <a:ea typeface="+mn-ea"/>
-              <a:cs typeface="+mn-cs"/>
-            </a:endParaRPr>
-          </a:p>
-        </p:txBody>
-      </p:sp>
-      <p:sp>
-        <p:nvSpPr>
-          <p:cNvPr id="13" name="Text 11"/>
-          <p:cNvSpPr/>
-          <p:nvPr/>
-        </p:nvSpPr>
-        <p:spPr>
-          <a:xfrm>
-            <a:off x="812800" y="5999479"/>
-            <a:ext cx="7194550" cy="274320"/>
-          </a:xfrm>
-          <a:prstGeom prst="rect">
-            <a:avLst/>
-          </a:prstGeom>
-          <a:noFill/>
-          <a:ln/>
-        </p:spPr>
-        <p:txBody>
-          <a:bodyPr wrap="square" lIns="0" tIns="0" rIns="0" bIns="0" rtlCol="0" anchor="t">
-            <a:normAutofit/>
-          </a:bodyPr>
-          <a:lstStyle/>
-          <a:p>
-            <a:pPr marL="0" marR="0" lvl="0" indent="0" algn="l" defTabSz="914400" rtl="0" eaLnBrk="1" fontAlgn="auto" latinLnBrk="0" hangingPunct="1">
-              <a:lnSpc>
-                <a:spcPts val="1960"/>
-              </a:lnSpc>
-              <a:spcBef>
-                <a:spcPts val="0"/>
-              </a:spcBef>
-              <a:spcAft>
-                <a:spcPts val="0"/>
-              </a:spcAft>
-              <a:buClrTx/>
-              <a:buSzTx/>
-              <a:buFontTx/>
-              <a:buNone/>
-              <a:tabLst/>
-              <a:defRPr/>
-            </a:pPr>
-            <a:endParaRPr kumimoji="0" lang="en-US" sz="1400" b="0" i="0" u="none" strike="noStrike" kern="1200" cap="none" spc="0" normalizeH="0" baseline="0" noProof="0" dirty="0">
-              <a:ln>
-                <a:noFill/>
-              </a:ln>
-              <a:solidFill>
-                <a:srgbClr val="2B2B30"/>
-              </a:solidFill>
-              <a:effectLst/>
-              <a:uLnTx/>
-              <a:uFillTx/>
-              <a:latin typeface="Public Sans"/>
-              <a:ea typeface="+mn-ea"/>
-              <a:cs typeface="+mn-cs"/>
-            </a:endParaRPr>
           </a:p>
         </p:txBody>
       </p:sp>

</xml_diff>